<commit_message>
lab-2: judge choice across local models and 15% chunk overlap experiment
- judge matrix (gpt-4.1 x2, Qwen2.5-14B x2, Qwen2.5-32B, Gemma3-12B) and blind
  adjudication of 25 disputed vertices; gpt-4.1 stays the judge
- with_overlap: whole-sentence overlap with neighbours inside a book, formulas
  and tables whole, edges never cut a sentence, under the GraphRAG chunk limit
- lab2 variants: overlap vs baseline vs re-index noise, clear deviations
- rework deck slides 3-4, rework.md sections 5-6, README, TASK3, speech

Co-Authored-By: Claude Opus 5.5 <noreply@anthropic.com>
</commit_message>
<xml_diff>
--- a/1-graph/lab-2/results/rework_2026-10-12.pptx
+++ b/1-graph/lab-2/results/rework_2026-10-12.pptx
@@ -7,6 +7,8 @@
   <p:sldIdLst>
     <p:sldId id="256" r:id="rId7"/>
     <p:sldId id="257" r:id="rId9"/>
+    <p:sldId id="258" r:id="rId10"/>
+    <p:sldId id="259" r:id="rId11"/>
   </p:sldIdLst>
   <p:sldSz cx="12191695" cy="6858000" type="screen4x3"/>
   <p:notesSz cx="6858000" cy="9144000"/>
@@ -1174,6 +1176,146 @@
           <a:p>
             <a:r>
               <a:t>Слева — дубликаты-переводы: пары «русское название — английское» по порогу косинуса. В чистом графе их меньше при любом пороге до 0,85; ниже начинаются ложные пары вроде «ТЕМПЕРАТУРА = HEATING TEMPERATURE». Справа — пары на одном языке: с понижением порога их число растёт в обоих графах, но в чистом быстрее. Примеры при 0,85–0,88: RECRYSTALLIZATION = STATIC RECRYSTALLIZATION, CONTROLLED ROLLING = LOW-TEMPERATURE CONTROLLED ROLLING — это общее и частное понятие, а не дубликат. Нормализация сделала названия вершин английскими и подробными, поэтому таких близких пар больше.</a:t>
+            </a:r>
+          </a:p>
+        </p:txBody>
+      </p:sp>
+      <p:sp>
+        <p:nvSpPr>
+          <p:cNvPr id="4" name="Slide Number Placeholder 3"/>
+          <p:cNvSpPr>
+            <a:spLocks noGrp="1"/>
+          </p:cNvSpPr>
+          <p:nvPr>
+            <p:ph type="sldNum" idx="5" sz="quarter"/>
+          </p:nvPr>
+        </p:nvSpPr>
+        <p:spPr/>
+      </p:sp>
+    </p:spTree>
+  </p:cSld>
+  <p:clrMapOvr>
+    <a:masterClrMapping/>
+  </p:clrMapOvr>
+</p:notes>
+</file>
+
+<file path=ppt/notesSlides/notesSlide3.xml><?xml version="1.0" encoding="utf-8"?>
+<p:notes xmlns:a="http://schemas.openxmlformats.org/drawingml/2006/main" xmlns:p="http://schemas.openxmlformats.org/presentationml/2006/main" xmlns:r="http://schemas.openxmlformats.org/officeDocument/2006/relationships">
+  <p:cSld>
+    <p:spTree>
+      <p:nvGrpSpPr>
+        <p:cNvPr id="1" name=""/>
+        <p:cNvGrpSpPr/>
+        <p:nvPr/>
+      </p:nvGrpSpPr>
+      <p:grpSpPr>
+        <a:xfrm>
+          <a:off x="0" y="0"/>
+          <a:ext cx="0" cy="0"/>
+          <a:chOff x="0" y="0"/>
+          <a:chExt cx="0" cy="0"/>
+        </a:xfrm>
+      </p:grpSpPr>
+      <p:sp>
+        <p:nvSpPr>
+          <p:cNvPr id="2" name="Slide Image Placeholder 1"/>
+          <p:cNvSpPr>
+            <a:spLocks noGrp="1"/>
+          </p:cNvSpPr>
+          <p:nvPr>
+            <p:ph type="sldImg" idx="2"/>
+          </p:nvPr>
+        </p:nvSpPr>
+        <p:spPr/>
+      </p:sp>
+      <p:sp>
+        <p:nvSpPr>
+          <p:cNvPr id="3" name="Notes Placeholder 2"/>
+          <p:cNvSpPr>
+            <a:spLocks noGrp="1"/>
+          </p:cNvSpPr>
+          <p:nvPr>
+            <p:ph type="body" idx="3" sz="quarter"/>
+          </p:nvPr>
+        </p:nvSpPr>
+        <p:spPr/>
+        <p:txBody>
+          <a:bodyPr/>
+          <a:lstStyle/>
+          <a:p>
+            <a:r>
+              <a:t>Те же 120 вершин каждого графа оценили gpt-4.1 дважды и три локальные модели через Ollama. Больше — не лучше: Qwen2.5-32B согласна с gpt-4.1 хуже, чем 14B, а на грязном графе находит вдвое меньше противоречий. Gemma3-12B не нашла ни одного. Локальные модели детерминированы — повтор Qwen-14B совпал один в один, — но обе Qwen считают чистый граф хуже грязного: это систематический сдвиг, а не шум. 25 вершин, где gpt-4.1 и обе Qwen расходятся, разметили вслепую по тексту: ни один судья там не надёжен, gpt-4.1 чуть точнее. С поправкой на разметку gpt-4.1 даёт 39,5% → 31,0% — направление то же. Оставляем судьёй gpt-4.1; разница графов по непротиворечивости — на границе точности судьи.</a:t>
+            </a:r>
+          </a:p>
+        </p:txBody>
+      </p:sp>
+      <p:sp>
+        <p:nvSpPr>
+          <p:cNvPr id="4" name="Slide Number Placeholder 3"/>
+          <p:cNvSpPr>
+            <a:spLocks noGrp="1"/>
+          </p:cNvSpPr>
+          <p:nvPr>
+            <p:ph type="sldNum" idx="5" sz="quarter"/>
+          </p:nvPr>
+        </p:nvSpPr>
+        <p:spPr/>
+      </p:sp>
+    </p:spTree>
+  </p:cSld>
+  <p:clrMapOvr>
+    <a:masterClrMapping/>
+  </p:clrMapOvr>
+</p:notes>
+</file>
+
+<file path=ppt/notesSlides/notesSlide4.xml><?xml version="1.0" encoding="utf-8"?>
+<p:notes xmlns:a="http://schemas.openxmlformats.org/drawingml/2006/main" xmlns:p="http://schemas.openxmlformats.org/presentationml/2006/main" xmlns:r="http://schemas.openxmlformats.org/officeDocument/2006/relationships">
+  <p:cSld>
+    <p:spTree>
+      <p:nvGrpSpPr>
+        <p:cNvPr id="1" name=""/>
+        <p:cNvGrpSpPr/>
+        <p:nvPr/>
+      </p:nvGrpSpPr>
+      <p:grpSpPr>
+        <a:xfrm>
+          <a:off x="0" y="0"/>
+          <a:ext cx="0" cy="0"/>
+          <a:chOff x="0" y="0"/>
+          <a:chExt cx="0" cy="0"/>
+        </a:xfrm>
+      </p:grpSpPr>
+      <p:sp>
+        <p:nvSpPr>
+          <p:cNvPr id="2" name="Slide Image Placeholder 1"/>
+          <p:cNvSpPr>
+            <a:spLocks noGrp="1"/>
+          </p:cNvSpPr>
+          <p:nvPr>
+            <p:ph type="sldImg" idx="2"/>
+          </p:nvPr>
+        </p:nvSpPr>
+        <p:spPr/>
+      </p:sp>
+      <p:sp>
+        <p:nvSpPr>
+          <p:cNvPr id="3" name="Notes Placeholder 2"/>
+          <p:cNvSpPr>
+            <a:spLocks noGrp="1"/>
+          </p:cNvSpPr>
+          <p:nvPr>
+            <p:ph type="body" idx="3" sz="quarter"/>
+          </p:nvPr>
+        </p:nvSpPr>
+        <p:spPr/>
+        <p:txBody>
+          <a:bodyPr/>
+          <a:lstStyle/>
+          <a:p>
+            <a:r>
+              <a:t>Каждый чанк получил по 7,5% соседей слева и справа: целые предложения, формулы и таблицы целиком, не больше 1200 токенов, только внутри книги. Базовые чанки те же — меняется один фактор. Чтобы отличить эффект от случайности GraphRAG, тот же чистый вход проиндексировали второй раз — это столбец «повтор». Отклонение явное, если оно больше удвоенного шума и не меньше 3 п. п. или 10%. Экстрактор берёт с чанка примерно одно и то же число сущностей независимо от длины, поэтому часть его внимания уходит на повтор соседнего текста: уникальных вершин меньше, связей между ними больше. Граф связнее, русская книга пришита к хабу CONTROLLED ROLLING, но рост циклов в основном звёздный, через хаб. Полнота и поиск хуже: MRR 0,77 → 0,73, соседние чанки стали похожи друг на друга. Непротиворечивость не изменилась.</a:t>
             </a:r>
           </a:p>
         </p:txBody>
@@ -4695,7 +4837,7 @@
                 </a:solidFill>
                 <a:latin typeface="Calibri"/>
               </a:rPr>
-              <a:t>1 / 2</a:t>
+              <a:t>1 / 4</a:t>
             </a:r>
           </a:p>
         </p:txBody>
@@ -4898,7 +5040,2514 @@
                 </a:solidFill>
                 <a:latin typeface="Calibri"/>
               </a:rPr>
-              <a:t>2 / 2</a:t>
+              <a:t>2 / 4</a:t>
+            </a:r>
+          </a:p>
+        </p:txBody>
+      </p:sp>
+    </p:spTree>
+  </p:cSld>
+  <p:clrMapOvr>
+    <a:masterClrMapping/>
+  </p:clrMapOvr>
+</p:sld>
+</file>
+
+<file path=ppt/slides/slide3.xml><?xml version="1.0" encoding="utf-8"?>
+<p:sld xmlns:a="http://schemas.openxmlformats.org/drawingml/2006/main" xmlns:p="http://schemas.openxmlformats.org/presentationml/2006/main" xmlns:r="http://schemas.openxmlformats.org/officeDocument/2006/relationships">
+  <p:cSld>
+    <p:spTree>
+      <p:nvGrpSpPr>
+        <p:cNvPr id="1" name=""/>
+        <p:cNvGrpSpPr/>
+        <p:nvPr/>
+      </p:nvGrpSpPr>
+      <p:grpSpPr/>
+      <p:sp>
+        <p:nvSpPr>
+          <p:cNvPr id="2" name="TextBox 1"/>
+          <p:cNvSpPr txBox="1"/>
+          <p:nvPr/>
+        </p:nvSpPr>
+        <p:spPr>
+          <a:xfrm>
+            <a:off x="548640" y="411480"/>
+            <a:ext cx="11064240" cy="731520"/>
+          </a:xfrm>
+          <a:prstGeom prst="rect">
+            <a:avLst/>
+          </a:prstGeom>
+          <a:noFill/>
+        </p:spPr>
+        <p:txBody>
+          <a:bodyPr wrap="square" lIns="0" rIns="0" tIns="0" bIns="0">
+            <a:spAutoFit/>
+          </a:bodyPr>
+          <a:lstStyle/>
+          <a:p>
+            <a:pPr algn="l">
+              <a:spcAft>
+                <a:spcPts val="600"/>
+              </a:spcAft>
+            </a:pPr>
+            <a:r>
+              <a:rPr sz="2800" b="1">
+                <a:solidFill>
+                  <a:srgbClr val="1F2328"/>
+                </a:solidFill>
+                <a:latin typeface="Calibri"/>
+              </a:rPr>
+              <a:t>Какой судья: gpt-4.1 или локальная модель</a:t>
+            </a:r>
+          </a:p>
+        </p:txBody>
+      </p:sp>
+      <p:graphicFrame>
+        <p:nvGraphicFramePr>
+          <p:cNvPr id="3" name="Table 2"/>
+          <p:cNvGraphicFramePr>
+            <a:graphicFrameLocks noGrp="1"/>
+          </p:cNvGraphicFramePr>
+          <p:nvPr/>
+        </p:nvGraphicFramePr>
+        <p:xfrm>
+          <a:off x="548640" y="1280160"/>
+          <a:ext cx="11064240" cy="2286000"/>
+        </p:xfrm>
+        <a:graphic>
+          <a:graphicData uri="http://schemas.openxmlformats.org/drawingml/2006/table">
+            <a:tbl>
+              <a:tblPr firstRow="1" bandRow="1">
+                <a:tableStyleId>{5C22544A-7EE6-4342-B048-85BDC9FD1C3A}</a:tableStyleId>
+              </a:tblPr>
+              <a:tblGrid>
+                <a:gridCol w="2377440"/>
+                <a:gridCol w="2743200"/>
+                <a:gridCol w="2377440"/>
+                <a:gridCol w="1828800"/>
+                <a:gridCol w="1737360"/>
+              </a:tblGrid>
+              <a:tr h="457200">
+                <a:tc>
+                  <a:txBody>
+                    <a:bodyPr/>
+                    <a:lstStyle/>
+                    <a:p>
+                      <a:pPr algn="l"/>
+                      <a:r>
+                        <a:rPr sz="1400" b="1">
+                          <a:solidFill>
+                            <a:srgbClr val="5F5E5A"/>
+                          </a:solidFill>
+                          <a:latin typeface="Calibri"/>
+                        </a:rPr>
+                        <a:t>Судья</a:t>
+                      </a:r>
+                    </a:p>
+                  </a:txBody>
+                  <a:tcPr marL="73152" marR="73152" marT="27432" marB="27432" anchor="ctr">
+                    <a:solidFill>
+                      <a:srgbClr val="F1F4F8"/>
+                    </a:solidFill>
+                  </a:tcPr>
+                </a:tc>
+                <a:tc>
+                  <a:txBody>
+                    <a:bodyPr/>
+                    <a:lstStyle/>
+                    <a:p>
+                      <a:pPr algn="r"/>
+                      <a:r>
+                        <a:rPr sz="1400" b="1">
+                          <a:solidFill>
+                            <a:srgbClr val="5F5E5A"/>
+                          </a:solidFill>
+                          <a:latin typeface="Calibri"/>
+                        </a:rPr>
+                        <a:t>Противоречий</a:t>
+                      </a:r>
+                    </a:p>
+                  </a:txBody>
+                  <a:tcPr marL="73152" marR="73152" marT="27432" marB="27432" anchor="ctr">
+                    <a:solidFill>
+                      <a:srgbClr val="F1F4F8"/>
+                    </a:solidFill>
+                  </a:tcPr>
+                </a:tc>
+                <a:tc>
+                  <a:txBody>
+                    <a:bodyPr/>
+                    <a:lstStyle/>
+                    <a:p>
+                      <a:pPr algn="l"/>
+                      <a:r>
+                        <a:rPr sz="1400" b="1">
+                          <a:solidFill>
+                            <a:srgbClr val="5F5E5A"/>
+                          </a:solidFill>
+                          <a:latin typeface="Calibri"/>
+                        </a:rPr>
+                        <a:t>κ с gpt-4.1</a:t>
+                      </a:r>
+                    </a:p>
+                  </a:txBody>
+                  <a:tcPr marL="73152" marR="73152" marT="27432" marB="27432" anchor="ctr">
+                    <a:solidFill>
+                      <a:srgbClr val="F1F4F8"/>
+                    </a:solidFill>
+                  </a:tcPr>
+                </a:tc>
+                <a:tc>
+                  <a:txBody>
+                    <a:bodyPr/>
+                    <a:lstStyle/>
+                    <a:p>
+                      <a:pPr algn="l"/>
+                      <a:r>
+                        <a:rPr sz="1400" b="1">
+                          <a:solidFill>
+                            <a:srgbClr val="5F5E5A"/>
+                          </a:solidFill>
+                          <a:latin typeface="Calibri"/>
+                        </a:rPr>
+                        <a:t>Повтор, κ</a:t>
+                      </a:r>
+                    </a:p>
+                  </a:txBody>
+                  <a:tcPr marL="73152" marR="73152" marT="27432" marB="27432" anchor="ctr">
+                    <a:solidFill>
+                      <a:srgbClr val="F1F4F8"/>
+                    </a:solidFill>
+                  </a:tcPr>
+                </a:tc>
+                <a:tc>
+                  <a:txBody>
+                    <a:bodyPr/>
+                    <a:lstStyle/>
+                    <a:p>
+                      <a:pPr algn="l"/>
+                      <a:r>
+                        <a:rPr sz="1400" b="1">
+                          <a:solidFill>
+                            <a:srgbClr val="5F5E5A"/>
+                          </a:solidFill>
+                          <a:latin typeface="Calibri"/>
+                        </a:rPr>
+                        <a:t>Верно на 25</a:t>
+                      </a:r>
+                    </a:p>
+                  </a:txBody>
+                  <a:tcPr marL="73152" marR="73152" marT="27432" marB="27432" anchor="ctr">
+                    <a:solidFill>
+                      <a:srgbClr val="F1F4F8"/>
+                    </a:solidFill>
+                  </a:tcPr>
+                </a:tc>
+              </a:tr>
+              <a:tr h="457200">
+                <a:tc>
+                  <a:txBody>
+                    <a:bodyPr/>
+                    <a:lstStyle/>
+                    <a:p>
+                      <a:pPr algn="l"/>
+                      <a:r>
+                        <a:rPr sz="1400" b="0">
+                          <a:solidFill>
+                            <a:srgbClr val="1F2328"/>
+                          </a:solidFill>
+                          <a:latin typeface="Calibri"/>
+                        </a:rPr>
+                        <a:t>gpt-4.1</a:t>
+                      </a:r>
+                    </a:p>
+                  </a:txBody>
+                  <a:tcPr marL="73152" marR="73152" marT="27432" marB="27432" anchor="ctr">
+                    <a:solidFill>
+                      <a:srgbClr val="FFFFFF"/>
+                    </a:solidFill>
+                  </a:tcPr>
+                </a:tc>
+                <a:tc>
+                  <a:txBody>
+                    <a:bodyPr/>
+                    <a:lstStyle/>
+                    <a:p>
+                      <a:pPr algn="r"/>
+                      <a:r>
+                        <a:rPr sz="1400" b="0">
+                          <a:solidFill>
+                            <a:srgbClr val="2A78D6"/>
+                          </a:solidFill>
+                          <a:latin typeface="Calibri"/>
+                        </a:rPr>
+                        <a:t>41,7% → 30,8%</a:t>
+                      </a:r>
+                    </a:p>
+                  </a:txBody>
+                  <a:tcPr marL="73152" marR="73152" marT="27432" marB="27432" anchor="ctr">
+                    <a:solidFill>
+                      <a:srgbClr val="FFFFFF"/>
+                    </a:solidFill>
+                  </a:tcPr>
+                </a:tc>
+                <a:tc>
+                  <a:txBody>
+                    <a:bodyPr/>
+                    <a:lstStyle/>
+                    <a:p>
+                      <a:pPr algn="l"/>
+                      <a:r>
+                        <a:rPr sz="1400" b="0">
+                          <a:solidFill>
+                            <a:srgbClr val="1F2328"/>
+                          </a:solidFill>
+                          <a:latin typeface="Calibri"/>
+                        </a:rPr>
+                        <a:t>—</a:t>
+                      </a:r>
+                    </a:p>
+                  </a:txBody>
+                  <a:tcPr marL="73152" marR="73152" marT="27432" marB="27432" anchor="ctr">
+                    <a:solidFill>
+                      <a:srgbClr val="FFFFFF"/>
+                    </a:solidFill>
+                  </a:tcPr>
+                </a:tc>
+                <a:tc>
+                  <a:txBody>
+                    <a:bodyPr/>
+                    <a:lstStyle/>
+                    <a:p>
+                      <a:pPr algn="l"/>
+                      <a:r>
+                        <a:rPr sz="1400" b="0">
+                          <a:solidFill>
+                            <a:srgbClr val="1F2328"/>
+                          </a:solidFill>
+                          <a:latin typeface="Calibri"/>
+                        </a:rPr>
+                        <a:t>0,83 / 0,90</a:t>
+                      </a:r>
+                    </a:p>
+                  </a:txBody>
+                  <a:tcPr marL="73152" marR="73152" marT="27432" marB="27432" anchor="ctr">
+                    <a:solidFill>
+                      <a:srgbClr val="FFFFFF"/>
+                    </a:solidFill>
+                  </a:tcPr>
+                </a:tc>
+                <a:tc>
+                  <a:txBody>
+                    <a:bodyPr/>
+                    <a:lstStyle/>
+                    <a:p>
+                      <a:pPr algn="l"/>
+                      <a:r>
+                        <a:rPr sz="1400" b="0">
+                          <a:solidFill>
+                            <a:srgbClr val="1F2328"/>
+                          </a:solidFill>
+                          <a:latin typeface="Calibri"/>
+                        </a:rPr>
+                        <a:t>14 из 25</a:t>
+                      </a:r>
+                    </a:p>
+                  </a:txBody>
+                  <a:tcPr marL="73152" marR="73152" marT="27432" marB="27432" anchor="ctr">
+                    <a:solidFill>
+                      <a:srgbClr val="FFFFFF"/>
+                    </a:solidFill>
+                  </a:tcPr>
+                </a:tc>
+              </a:tr>
+              <a:tr h="457200">
+                <a:tc>
+                  <a:txBody>
+                    <a:bodyPr/>
+                    <a:lstStyle/>
+                    <a:p>
+                      <a:pPr algn="l"/>
+                      <a:r>
+                        <a:rPr sz="1400" b="0">
+                          <a:solidFill>
+                            <a:srgbClr val="1F2328"/>
+                          </a:solidFill>
+                          <a:latin typeface="Calibri"/>
+                        </a:rPr>
+                        <a:t>Qwen2.5-14B</a:t>
+                      </a:r>
+                    </a:p>
+                  </a:txBody>
+                  <a:tcPr marL="73152" marR="73152" marT="27432" marB="27432" anchor="ctr">
+                    <a:solidFill>
+                      <a:srgbClr val="FFFFFF"/>
+                    </a:solidFill>
+                  </a:tcPr>
+                </a:tc>
+                <a:tc>
+                  <a:txBody>
+                    <a:bodyPr/>
+                    <a:lstStyle/>
+                    <a:p>
+                      <a:pPr algn="r"/>
+                      <a:r>
+                        <a:rPr sz="1400" b="0">
+                          <a:solidFill>
+                            <a:srgbClr val="2A78D6"/>
+                          </a:solidFill>
+                          <a:latin typeface="Calibri"/>
+                        </a:rPr>
+                        <a:t>35,8% → 44,2%</a:t>
+                      </a:r>
+                    </a:p>
+                  </a:txBody>
+                  <a:tcPr marL="73152" marR="73152" marT="27432" marB="27432" anchor="ctr">
+                    <a:solidFill>
+                      <a:srgbClr val="FFFFFF"/>
+                    </a:solidFill>
+                  </a:tcPr>
+                </a:tc>
+                <a:tc>
+                  <a:txBody>
+                    <a:bodyPr/>
+                    <a:lstStyle/>
+                    <a:p>
+                      <a:pPr algn="l"/>
+                      <a:r>
+                        <a:rPr sz="1400" b="0">
+                          <a:solidFill>
+                            <a:srgbClr val="1F2328"/>
+                          </a:solidFill>
+                          <a:latin typeface="Calibri"/>
+                        </a:rPr>
+                        <a:t>0,35 / 0,34</a:t>
+                      </a:r>
+                    </a:p>
+                  </a:txBody>
+                  <a:tcPr marL="73152" marR="73152" marT="27432" marB="27432" anchor="ctr">
+                    <a:solidFill>
+                      <a:srgbClr val="FFFFFF"/>
+                    </a:solidFill>
+                  </a:tcPr>
+                </a:tc>
+                <a:tc>
+                  <a:txBody>
+                    <a:bodyPr/>
+                    <a:lstStyle/>
+                    <a:p>
+                      <a:pPr algn="l"/>
+                      <a:r>
+                        <a:rPr sz="1400" b="0">
+                          <a:solidFill>
+                            <a:srgbClr val="1F2328"/>
+                          </a:solidFill>
+                          <a:latin typeface="Calibri"/>
+                        </a:rPr>
+                        <a:t>1,00 / 1,00</a:t>
+                      </a:r>
+                    </a:p>
+                  </a:txBody>
+                  <a:tcPr marL="73152" marR="73152" marT="27432" marB="27432" anchor="ctr">
+                    <a:solidFill>
+                      <a:srgbClr val="FFFFFF"/>
+                    </a:solidFill>
+                  </a:tcPr>
+                </a:tc>
+                <a:tc>
+                  <a:txBody>
+                    <a:bodyPr/>
+                    <a:lstStyle/>
+                    <a:p>
+                      <a:pPr algn="l"/>
+                      <a:r>
+                        <a:rPr sz="1400" b="0">
+                          <a:solidFill>
+                            <a:srgbClr val="1F2328"/>
+                          </a:solidFill>
+                          <a:latin typeface="Calibri"/>
+                        </a:rPr>
+                        <a:t>11 из 25</a:t>
+                      </a:r>
+                    </a:p>
+                  </a:txBody>
+                  <a:tcPr marL="73152" marR="73152" marT="27432" marB="27432" anchor="ctr">
+                    <a:solidFill>
+                      <a:srgbClr val="FFFFFF"/>
+                    </a:solidFill>
+                  </a:tcPr>
+                </a:tc>
+              </a:tr>
+              <a:tr h="457200">
+                <a:tc>
+                  <a:txBody>
+                    <a:bodyPr/>
+                    <a:lstStyle/>
+                    <a:p>
+                      <a:pPr algn="l"/>
+                      <a:r>
+                        <a:rPr sz="1400" b="0">
+                          <a:solidFill>
+                            <a:srgbClr val="1F2328"/>
+                          </a:solidFill>
+                          <a:latin typeface="Calibri"/>
+                        </a:rPr>
+                        <a:t>Qwen2.5-32B</a:t>
+                      </a:r>
+                    </a:p>
+                  </a:txBody>
+                  <a:tcPr marL="73152" marR="73152" marT="27432" marB="27432" anchor="ctr">
+                    <a:solidFill>
+                      <a:srgbClr val="FFFFFF"/>
+                    </a:solidFill>
+                  </a:tcPr>
+                </a:tc>
+                <a:tc>
+                  <a:txBody>
+                    <a:bodyPr/>
+                    <a:lstStyle/>
+                    <a:p>
+                      <a:pPr algn="r"/>
+                      <a:r>
+                        <a:rPr sz="1400" b="0">
+                          <a:solidFill>
+                            <a:srgbClr val="2A78D6"/>
+                          </a:solidFill>
+                          <a:latin typeface="Calibri"/>
+                        </a:rPr>
+                        <a:t>17,5% → 34,2%</a:t>
+                      </a:r>
+                    </a:p>
+                  </a:txBody>
+                  <a:tcPr marL="73152" marR="73152" marT="27432" marB="27432" anchor="ctr">
+                    <a:solidFill>
+                      <a:srgbClr val="FFFFFF"/>
+                    </a:solidFill>
+                  </a:tcPr>
+                </a:tc>
+                <a:tc>
+                  <a:txBody>
+                    <a:bodyPr/>
+                    <a:lstStyle/>
+                    <a:p>
+                      <a:pPr algn="l"/>
+                      <a:r>
+                        <a:rPr sz="1400" b="0">
+                          <a:solidFill>
+                            <a:srgbClr val="1F2328"/>
+                          </a:solidFill>
+                          <a:latin typeface="Calibri"/>
+                        </a:rPr>
+                        <a:t>0,20 / 0,32</a:t>
+                      </a:r>
+                    </a:p>
+                  </a:txBody>
+                  <a:tcPr marL="73152" marR="73152" marT="27432" marB="27432" anchor="ctr">
+                    <a:solidFill>
+                      <a:srgbClr val="FFFFFF"/>
+                    </a:solidFill>
+                  </a:tcPr>
+                </a:tc>
+                <a:tc>
+                  <a:txBody>
+                    <a:bodyPr/>
+                    <a:lstStyle/>
+                    <a:p>
+                      <a:pPr algn="l"/>
+                      <a:r>
+                        <a:rPr sz="1400" b="0">
+                          <a:solidFill>
+                            <a:srgbClr val="1F2328"/>
+                          </a:solidFill>
+                          <a:latin typeface="Calibri"/>
+                        </a:rPr>
+                        <a:t>—</a:t>
+                      </a:r>
+                    </a:p>
+                  </a:txBody>
+                  <a:tcPr marL="73152" marR="73152" marT="27432" marB="27432" anchor="ctr">
+                    <a:solidFill>
+                      <a:srgbClr val="FFFFFF"/>
+                    </a:solidFill>
+                  </a:tcPr>
+                </a:tc>
+                <a:tc>
+                  <a:txBody>
+                    <a:bodyPr/>
+                    <a:lstStyle/>
+                    <a:p>
+                      <a:pPr algn="l"/>
+                      <a:r>
+                        <a:rPr sz="1400" b="0">
+                          <a:solidFill>
+                            <a:srgbClr val="1F2328"/>
+                          </a:solidFill>
+                          <a:latin typeface="Calibri"/>
+                        </a:rPr>
+                        <a:t>11 из 25</a:t>
+                      </a:r>
+                    </a:p>
+                  </a:txBody>
+                  <a:tcPr marL="73152" marR="73152" marT="27432" marB="27432" anchor="ctr">
+                    <a:solidFill>
+                      <a:srgbClr val="FFFFFF"/>
+                    </a:solidFill>
+                  </a:tcPr>
+                </a:tc>
+              </a:tr>
+              <a:tr h="457200">
+                <a:tc>
+                  <a:txBody>
+                    <a:bodyPr/>
+                    <a:lstStyle/>
+                    <a:p>
+                      <a:pPr algn="l"/>
+                      <a:r>
+                        <a:rPr sz="1400" b="0">
+                          <a:solidFill>
+                            <a:srgbClr val="1F2328"/>
+                          </a:solidFill>
+                          <a:latin typeface="Calibri"/>
+                        </a:rPr>
+                        <a:t>Gemma3-12B</a:t>
+                      </a:r>
+                    </a:p>
+                  </a:txBody>
+                  <a:tcPr marL="73152" marR="73152" marT="27432" marB="27432" anchor="ctr">
+                    <a:solidFill>
+                      <a:srgbClr val="FFFFFF"/>
+                    </a:solidFill>
+                  </a:tcPr>
+                </a:tc>
+                <a:tc>
+                  <a:txBody>
+                    <a:bodyPr/>
+                    <a:lstStyle/>
+                    <a:p>
+                      <a:pPr algn="r"/>
+                      <a:r>
+                        <a:rPr sz="1400" b="0">
+                          <a:solidFill>
+                            <a:srgbClr val="2A78D6"/>
+                          </a:solidFill>
+                          <a:latin typeface="Calibri"/>
+                        </a:rPr>
+                        <a:t>0,0% → 0,0%</a:t>
+                      </a:r>
+                    </a:p>
+                  </a:txBody>
+                  <a:tcPr marL="73152" marR="73152" marT="27432" marB="27432" anchor="ctr">
+                    <a:solidFill>
+                      <a:srgbClr val="FFFFFF"/>
+                    </a:solidFill>
+                  </a:tcPr>
+                </a:tc>
+                <a:tc>
+                  <a:txBody>
+                    <a:bodyPr/>
+                    <a:lstStyle/>
+                    <a:p>
+                      <a:pPr algn="l"/>
+                      <a:r>
+                        <a:rPr sz="1400" b="0">
+                          <a:solidFill>
+                            <a:srgbClr val="1F2328"/>
+                          </a:solidFill>
+                          <a:latin typeface="Calibri"/>
+                        </a:rPr>
+                        <a:t>0,00 / 0,00</a:t>
+                      </a:r>
+                    </a:p>
+                  </a:txBody>
+                  <a:tcPr marL="73152" marR="73152" marT="27432" marB="27432" anchor="ctr">
+                    <a:solidFill>
+                      <a:srgbClr val="FFFFFF"/>
+                    </a:solidFill>
+                  </a:tcPr>
+                </a:tc>
+                <a:tc>
+                  <a:txBody>
+                    <a:bodyPr/>
+                    <a:lstStyle/>
+                    <a:p>
+                      <a:pPr algn="l"/>
+                      <a:r>
+                        <a:rPr sz="1400" b="0">
+                          <a:solidFill>
+                            <a:srgbClr val="1F2328"/>
+                          </a:solidFill>
+                          <a:latin typeface="Calibri"/>
+                        </a:rPr>
+                        <a:t>—</a:t>
+                      </a:r>
+                    </a:p>
+                  </a:txBody>
+                  <a:tcPr marL="73152" marR="73152" marT="27432" marB="27432" anchor="ctr">
+                    <a:solidFill>
+                      <a:srgbClr val="FFFFFF"/>
+                    </a:solidFill>
+                  </a:tcPr>
+                </a:tc>
+                <a:tc>
+                  <a:txBody>
+                    <a:bodyPr/>
+                    <a:lstStyle/>
+                    <a:p>
+                      <a:pPr algn="l"/>
+                      <a:r>
+                        <a:rPr sz="1400" b="0">
+                          <a:solidFill>
+                            <a:srgbClr val="1F2328"/>
+                          </a:solidFill>
+                          <a:latin typeface="Calibri"/>
+                        </a:rPr>
+                        <a:t>12 из 25</a:t>
+                      </a:r>
+                    </a:p>
+                  </a:txBody>
+                  <a:tcPr marL="73152" marR="73152" marT="27432" marB="27432" anchor="ctr">
+                    <a:solidFill>
+                      <a:srgbClr val="FFFFFF"/>
+                    </a:solidFill>
+                  </a:tcPr>
+                </a:tc>
+              </a:tr>
+            </a:tbl>
+          </a:graphicData>
+        </a:graphic>
+      </p:graphicFrame>
+      <p:sp>
+        <p:nvSpPr>
+          <p:cNvPr id="4" name="TextBox 3"/>
+          <p:cNvSpPr txBox="1"/>
+          <p:nvPr/>
+        </p:nvSpPr>
+        <p:spPr>
+          <a:xfrm>
+            <a:off x="548640" y="3931920"/>
+            <a:ext cx="11064240" cy="2194560"/>
+          </a:xfrm>
+          <a:prstGeom prst="rect">
+            <a:avLst/>
+          </a:prstGeom>
+          <a:noFill/>
+        </p:spPr>
+        <p:txBody>
+          <a:bodyPr wrap="square" lIns="0" rIns="0" tIns="0" bIns="0">
+            <a:spAutoFit/>
+          </a:bodyPr>
+          <a:lstStyle/>
+          <a:p>
+            <a:pPr algn="l">
+              <a:spcAft>
+                <a:spcPts val="800"/>
+              </a:spcAft>
+            </a:pPr>
+            <a:r>
+              <a:rPr sz="1500" b="0">
+                <a:solidFill>
+                  <a:srgbClr val="1F2328"/>
+                </a:solidFill>
+                <a:latin typeface="Calibri"/>
+              </a:rPr>
+              <a:t>Больше параметров не помогает: 32B согласна с gpt-4.1 хуже, чем 14B, и на грязном графе находит вдвое меньше противоречий</a:t>
+            </a:r>
+          </a:p>
+          <a:p>
+            <a:pPr algn="l">
+              <a:spcAft>
+                <a:spcPts val="800"/>
+              </a:spcAft>
+            </a:pPr>
+            <a:r>
+              <a:rPr sz="1500" b="0">
+                <a:solidFill>
+                  <a:srgbClr val="1F2328"/>
+                </a:solidFill>
+                <a:latin typeface="Calibri"/>
+              </a:rPr>
+              <a:t>Gemma3-12B не находит противоречий вообще; «всегда нет» на спорных вершинах угадывает не хуже Qwen</a:t>
+            </a:r>
+          </a:p>
+          <a:p>
+            <a:pPr algn="l">
+              <a:spcAft>
+                <a:spcPts val="800"/>
+              </a:spcAft>
+            </a:pPr>
+            <a:r>
+              <a:rPr sz="1500" b="0">
+                <a:solidFill>
+                  <a:srgbClr val="1F2328"/>
+                </a:solidFill>
+                <a:latin typeface="Calibri"/>
+              </a:rPr>
+              <a:t>Обе Qwen ставят чистый граф ниже грязного — систематический сдвиг, а не шум</a:t>
+            </a:r>
+          </a:p>
+          <a:p>
+            <a:pPr algn="l">
+              <a:spcAft>
+                <a:spcPts val="800"/>
+              </a:spcAft>
+            </a:pPr>
+            <a:r>
+              <a:rPr sz="1500" b="0">
+                <a:solidFill>
+                  <a:srgbClr val="1F2328"/>
+                </a:solidFill>
+                <a:latin typeface="Calibri"/>
+              </a:rPr>
+              <a:t>Слепая разметка 25 спорных вершин: с поправкой gpt-4.1 даёт 39,5% → 31,0%. Судья — gpt-4.1</a:t>
+            </a:r>
+          </a:p>
+        </p:txBody>
+      </p:sp>
+      <p:sp>
+        <p:nvSpPr>
+          <p:cNvPr id="5" name="TextBox 4"/>
+          <p:cNvSpPr txBox="1"/>
+          <p:nvPr/>
+        </p:nvSpPr>
+        <p:spPr>
+          <a:xfrm>
+            <a:off x="548640" y="6263640"/>
+            <a:ext cx="11064240" cy="365760"/>
+          </a:xfrm>
+          <a:prstGeom prst="rect">
+            <a:avLst/>
+          </a:prstGeom>
+          <a:noFill/>
+        </p:spPr>
+        <p:txBody>
+          <a:bodyPr wrap="square" lIns="0" rIns="0" tIns="0" bIns="0">
+            <a:spAutoFit/>
+          </a:bodyPr>
+          <a:lstStyle/>
+          <a:p>
+            <a:pPr algn="l">
+              <a:spcAft>
+                <a:spcPts val="600"/>
+              </a:spcAft>
+            </a:pPr>
+            <a:r>
+              <a:rPr sz="1200" b="0">
+                <a:solidFill>
+                  <a:srgbClr val="5F5E5A"/>
+                </a:solidFill>
+                <a:latin typeface="Calibri"/>
+              </a:rPr>
+              <a:t>Противоречий — доля вершин, грязный → чистый; κ — каппа Коэна по флагу «есть противоречие», грязный / чистый; «Верно на 25» — совпадение со слепой разметкой спорных вершин</a:t>
+            </a:r>
+          </a:p>
+        </p:txBody>
+      </p:sp>
+      <p:sp>
+        <p:nvSpPr>
+          <p:cNvPr id="6" name="TextBox 5"/>
+          <p:cNvSpPr txBox="1"/>
+          <p:nvPr/>
+        </p:nvSpPr>
+        <p:spPr>
+          <a:xfrm>
+            <a:off x="10725912" y="6528816"/>
+            <a:ext cx="914400" cy="237744"/>
+          </a:xfrm>
+          <a:prstGeom prst="rect">
+            <a:avLst/>
+          </a:prstGeom>
+          <a:noFill/>
+        </p:spPr>
+        <p:txBody>
+          <a:bodyPr wrap="square" lIns="0" rIns="0" tIns="0" bIns="0">
+            <a:spAutoFit/>
+          </a:bodyPr>
+          <a:lstStyle/>
+          <a:p>
+            <a:pPr algn="r">
+              <a:spcAft>
+                <a:spcPts val="600"/>
+              </a:spcAft>
+            </a:pPr>
+            <a:r>
+              <a:rPr sz="1100" b="0">
+                <a:solidFill>
+                  <a:srgbClr val="5F5E5A"/>
+                </a:solidFill>
+                <a:latin typeface="Calibri"/>
+              </a:rPr>
+              <a:t>3 / 4</a:t>
+            </a:r>
+          </a:p>
+        </p:txBody>
+      </p:sp>
+    </p:spTree>
+  </p:cSld>
+  <p:clrMapOvr>
+    <a:masterClrMapping/>
+  </p:clrMapOvr>
+</p:sld>
+</file>
+
+<file path=ppt/slides/slide4.xml><?xml version="1.0" encoding="utf-8"?>
+<p:sld xmlns:a="http://schemas.openxmlformats.org/drawingml/2006/main" xmlns:p="http://schemas.openxmlformats.org/presentationml/2006/main" xmlns:r="http://schemas.openxmlformats.org/officeDocument/2006/relationships">
+  <p:cSld>
+    <p:spTree>
+      <p:nvGrpSpPr>
+        <p:cNvPr id="1" name=""/>
+        <p:cNvGrpSpPr/>
+        <p:nvPr/>
+      </p:nvGrpSpPr>
+      <p:grpSpPr/>
+      <p:sp>
+        <p:nvSpPr>
+          <p:cNvPr id="2" name="TextBox 1"/>
+          <p:cNvSpPr txBox="1"/>
+          <p:nvPr/>
+        </p:nvSpPr>
+        <p:spPr>
+          <a:xfrm>
+            <a:off x="548640" y="411480"/>
+            <a:ext cx="11064240" cy="731520"/>
+          </a:xfrm>
+          <a:prstGeom prst="rect">
+            <a:avLst/>
+          </a:prstGeom>
+          <a:noFill/>
+        </p:spPr>
+        <p:txBody>
+          <a:bodyPr wrap="square" lIns="0" rIns="0" tIns="0" bIns="0">
+            <a:spAutoFit/>
+          </a:bodyPr>
+          <a:lstStyle/>
+          <a:p>
+            <a:pPr algn="l">
+              <a:spcAft>
+                <a:spcPts val="600"/>
+              </a:spcAft>
+            </a:pPr>
+            <a:r>
+              <a:rPr sz="2800" b="1">
+                <a:solidFill>
+                  <a:srgbClr val="1F2328"/>
+                </a:solidFill>
+                <a:latin typeface="Calibri"/>
+              </a:rPr>
+              <a:t>Чанки с пересечением 15%: граф связнее, но беднее</a:t>
+            </a:r>
+          </a:p>
+        </p:txBody>
+      </p:sp>
+      <p:graphicFrame>
+        <p:nvGraphicFramePr>
+          <p:cNvPr id="3" name="Table 2"/>
+          <p:cNvGraphicFramePr>
+            <a:graphicFrameLocks noGrp="1"/>
+          </p:cNvGraphicFramePr>
+          <p:nvPr/>
+        </p:nvGraphicFramePr>
+        <p:xfrm>
+          <a:off x="548640" y="1280160"/>
+          <a:ext cx="7315200" cy="4608576"/>
+        </p:xfrm>
+        <a:graphic>
+          <a:graphicData uri="http://schemas.openxmlformats.org/drawingml/2006/table">
+            <a:tbl>
+              <a:tblPr firstRow="1" bandRow="1">
+                <a:tableStyleId>{5C22544A-7EE6-4342-B048-85BDC9FD1C3A}</a:tableStyleId>
+              </a:tblPr>
+              <a:tblGrid>
+                <a:gridCol w="2743200"/>
+                <a:gridCol w="1188720"/>
+                <a:gridCol w="1188720"/>
+                <a:gridCol w="1463040"/>
+                <a:gridCol w="731520"/>
+              </a:tblGrid>
+              <a:tr h="384048">
+                <a:tc>
+                  <a:txBody>
+                    <a:bodyPr/>
+                    <a:lstStyle/>
+                    <a:p>
+                      <a:pPr algn="l"/>
+                      <a:r>
+                        <a:rPr sz="1300" b="1">
+                          <a:solidFill>
+                            <a:srgbClr val="5F5E5A"/>
+                          </a:solidFill>
+                          <a:latin typeface="Calibri"/>
+                        </a:rPr>
+                        <a:t>Чистый граф</a:t>
+                      </a:r>
+                    </a:p>
+                  </a:txBody>
+                  <a:tcPr marL="73152" marR="73152" marT="27432" marB="27432" anchor="ctr">
+                    <a:solidFill>
+                      <a:srgbClr val="F1F4F8"/>
+                    </a:solidFill>
+                  </a:tcPr>
+                </a:tc>
+                <a:tc>
+                  <a:txBody>
+                    <a:bodyPr/>
+                    <a:lstStyle/>
+                    <a:p>
+                      <a:pPr algn="l"/>
+                      <a:r>
+                        <a:rPr sz="1300" b="1">
+                          <a:solidFill>
+                            <a:srgbClr val="5F5E5A"/>
+                          </a:solidFill>
+                          <a:latin typeface="Calibri"/>
+                        </a:rPr>
+                        <a:t>база</a:t>
+                      </a:r>
+                    </a:p>
+                  </a:txBody>
+                  <a:tcPr marL="73152" marR="73152" marT="27432" marB="27432" anchor="ctr">
+                    <a:solidFill>
+                      <a:srgbClr val="F1F4F8"/>
+                    </a:solidFill>
+                  </a:tcPr>
+                </a:tc>
+                <a:tc>
+                  <a:txBody>
+                    <a:bodyPr/>
+                    <a:lstStyle/>
+                    <a:p>
+                      <a:pPr algn="l"/>
+                      <a:r>
+                        <a:rPr sz="1300" b="1">
+                          <a:solidFill>
+                            <a:srgbClr val="5F5E5A"/>
+                          </a:solidFill>
+                          <a:latin typeface="Calibri"/>
+                        </a:rPr>
+                        <a:t>повтор</a:t>
+                      </a:r>
+                    </a:p>
+                  </a:txBody>
+                  <a:tcPr marL="73152" marR="73152" marT="27432" marB="27432" anchor="ctr">
+                    <a:solidFill>
+                      <a:srgbClr val="F1F4F8"/>
+                    </a:solidFill>
+                  </a:tcPr>
+                </a:tc>
+                <a:tc>
+                  <a:txBody>
+                    <a:bodyPr/>
+                    <a:lstStyle/>
+                    <a:p>
+                      <a:pPr algn="r"/>
+                      <a:r>
+                        <a:rPr sz="1300" b="1">
+                          <a:solidFill>
+                            <a:srgbClr val="5F5E5A"/>
+                          </a:solidFill>
+                          <a:latin typeface="Calibri"/>
+                        </a:rPr>
+                        <a:t>пересечение</a:t>
+                      </a:r>
+                    </a:p>
+                  </a:txBody>
+                  <a:tcPr marL="73152" marR="73152" marT="27432" marB="27432" anchor="ctr">
+                    <a:solidFill>
+                      <a:srgbClr val="F1F4F8"/>
+                    </a:solidFill>
+                  </a:tcPr>
+                </a:tc>
+                <a:tc>
+                  <a:txBody>
+                    <a:bodyPr/>
+                    <a:lstStyle/>
+                    <a:p>
+                      <a:pPr algn="l"/>
+                      <a:r>
+                        <a:rPr sz="1300" b="1">
+                          <a:solidFill>
+                            <a:srgbClr val="5F5E5A"/>
+                          </a:solidFill>
+                          <a:latin typeface="Calibri"/>
+                        </a:rPr>
+                        <a:t>явно</a:t>
+                      </a:r>
+                    </a:p>
+                  </a:txBody>
+                  <a:tcPr marL="73152" marR="73152" marT="27432" marB="27432" anchor="ctr">
+                    <a:solidFill>
+                      <a:srgbClr val="F1F4F8"/>
+                    </a:solidFill>
+                  </a:tcPr>
+                </a:tc>
+              </a:tr>
+              <a:tr h="384048">
+                <a:tc>
+                  <a:txBody>
+                    <a:bodyPr/>
+                    <a:lstStyle/>
+                    <a:p>
+                      <a:pPr algn="l"/>
+                      <a:r>
+                        <a:rPr sz="1300" b="0">
+                          <a:solidFill>
+                            <a:srgbClr val="1F2328"/>
+                          </a:solidFill>
+                          <a:latin typeface="Calibri"/>
+                        </a:rPr>
+                        <a:t>Токенов на входе</a:t>
+                      </a:r>
+                    </a:p>
+                  </a:txBody>
+                  <a:tcPr marL="73152" marR="73152" marT="27432" marB="27432" anchor="ctr">
+                    <a:solidFill>
+                      <a:srgbClr val="FFFFFF"/>
+                    </a:solidFill>
+                  </a:tcPr>
+                </a:tc>
+                <a:tc>
+                  <a:txBody>
+                    <a:bodyPr/>
+                    <a:lstStyle/>
+                    <a:p>
+                      <a:pPr algn="l"/>
+                      <a:r>
+                        <a:rPr sz="1300" b="0">
+                          <a:solidFill>
+                            <a:srgbClr val="1F2328"/>
+                          </a:solidFill>
+                          <a:latin typeface="Calibri"/>
+                        </a:rPr>
+                        <a:t>24 893</a:t>
+                      </a:r>
+                    </a:p>
+                  </a:txBody>
+                  <a:tcPr marL="73152" marR="73152" marT="27432" marB="27432" anchor="ctr">
+                    <a:solidFill>
+                      <a:srgbClr val="FFFFFF"/>
+                    </a:solidFill>
+                  </a:tcPr>
+                </a:tc>
+                <a:tc>
+                  <a:txBody>
+                    <a:bodyPr/>
+                    <a:lstStyle/>
+                    <a:p>
+                      <a:pPr algn="l"/>
+                      <a:r>
+                        <a:rPr sz="1300" b="0">
+                          <a:solidFill>
+                            <a:srgbClr val="1F2328"/>
+                          </a:solidFill>
+                          <a:latin typeface="Calibri"/>
+                        </a:rPr>
+                        <a:t>24 893</a:t>
+                      </a:r>
+                    </a:p>
+                  </a:txBody>
+                  <a:tcPr marL="73152" marR="73152" marT="27432" marB="27432" anchor="ctr">
+                    <a:solidFill>
+                      <a:srgbClr val="FFFFFF"/>
+                    </a:solidFill>
+                  </a:tcPr>
+                </a:tc>
+                <a:tc>
+                  <a:txBody>
+                    <a:bodyPr/>
+                    <a:lstStyle/>
+                    <a:p>
+                      <a:pPr algn="r"/>
+                      <a:r>
+                        <a:rPr sz="1300" b="0">
+                          <a:solidFill>
+                            <a:srgbClr val="2A78D6"/>
+                          </a:solidFill>
+                          <a:latin typeface="Calibri"/>
+                        </a:rPr>
+                        <a:t>28 038</a:t>
+                      </a:r>
+                    </a:p>
+                  </a:txBody>
+                  <a:tcPr marL="73152" marR="73152" marT="27432" marB="27432" anchor="ctr">
+                    <a:solidFill>
+                      <a:srgbClr val="FFFFFF"/>
+                    </a:solidFill>
+                  </a:tcPr>
+                </a:tc>
+                <a:tc>
+                  <a:txBody>
+                    <a:bodyPr/>
+                    <a:lstStyle/>
+                    <a:p>
+                      <a:pPr algn="l"/>
+                      <a:r>
+                        <a:rPr sz="1300" b="0">
+                          <a:solidFill>
+                            <a:srgbClr val="1F2328"/>
+                          </a:solidFill>
+                          <a:latin typeface="Calibri"/>
+                        </a:rPr>
+                        <a:t>да</a:t>
+                      </a:r>
+                    </a:p>
+                  </a:txBody>
+                  <a:tcPr marL="73152" marR="73152" marT="27432" marB="27432" anchor="ctr">
+                    <a:solidFill>
+                      <a:srgbClr val="FFFFFF"/>
+                    </a:solidFill>
+                  </a:tcPr>
+                </a:tc>
+              </a:tr>
+              <a:tr h="384048">
+                <a:tc>
+                  <a:txBody>
+                    <a:bodyPr/>
+                    <a:lstStyle/>
+                    <a:p>
+                      <a:pPr algn="l"/>
+                      <a:r>
+                        <a:rPr sz="1300" b="0">
+                          <a:solidFill>
+                            <a:srgbClr val="1F2328"/>
+                          </a:solidFill>
+                          <a:latin typeface="Calibri"/>
+                        </a:rPr>
+                        <a:t>Вершин</a:t>
+                      </a:r>
+                    </a:p>
+                  </a:txBody>
+                  <a:tcPr marL="73152" marR="73152" marT="27432" marB="27432" anchor="ctr">
+                    <a:solidFill>
+                      <a:srgbClr val="FFFFFF"/>
+                    </a:solidFill>
+                  </a:tcPr>
+                </a:tc>
+                <a:tc>
+                  <a:txBody>
+                    <a:bodyPr/>
+                    <a:lstStyle/>
+                    <a:p>
+                      <a:pPr algn="l"/>
+                      <a:r>
+                        <a:rPr sz="1300" b="0">
+                          <a:solidFill>
+                            <a:srgbClr val="1F2328"/>
+                          </a:solidFill>
+                          <a:latin typeface="Calibri"/>
+                        </a:rPr>
+                        <a:t>424</a:t>
+                      </a:r>
+                    </a:p>
+                  </a:txBody>
+                  <a:tcPr marL="73152" marR="73152" marT="27432" marB="27432" anchor="ctr">
+                    <a:solidFill>
+                      <a:srgbClr val="FFFFFF"/>
+                    </a:solidFill>
+                  </a:tcPr>
+                </a:tc>
+                <a:tc>
+                  <a:txBody>
+                    <a:bodyPr/>
+                    <a:lstStyle/>
+                    <a:p>
+                      <a:pPr algn="l"/>
+                      <a:r>
+                        <a:rPr sz="1300" b="0">
+                          <a:solidFill>
+                            <a:srgbClr val="1F2328"/>
+                          </a:solidFill>
+                          <a:latin typeface="Calibri"/>
+                        </a:rPr>
+                        <a:t>389</a:t>
+                      </a:r>
+                    </a:p>
+                  </a:txBody>
+                  <a:tcPr marL="73152" marR="73152" marT="27432" marB="27432" anchor="ctr">
+                    <a:solidFill>
+                      <a:srgbClr val="FFFFFF"/>
+                    </a:solidFill>
+                  </a:tcPr>
+                </a:tc>
+                <a:tc>
+                  <a:txBody>
+                    <a:bodyPr/>
+                    <a:lstStyle/>
+                    <a:p>
+                      <a:pPr algn="r"/>
+                      <a:r>
+                        <a:rPr sz="1300" b="0">
+                          <a:solidFill>
+                            <a:srgbClr val="2A78D6"/>
+                          </a:solidFill>
+                          <a:latin typeface="Calibri"/>
+                        </a:rPr>
+                        <a:t>346</a:t>
+                      </a:r>
+                    </a:p>
+                  </a:txBody>
+                  <a:tcPr marL="73152" marR="73152" marT="27432" marB="27432" anchor="ctr">
+                    <a:solidFill>
+                      <a:srgbClr val="FFFFFF"/>
+                    </a:solidFill>
+                  </a:tcPr>
+                </a:tc>
+                <a:tc>
+                  <a:txBody>
+                    <a:bodyPr/>
+                    <a:lstStyle/>
+                    <a:p>
+                      <a:pPr algn="l"/>
+                      <a:r>
+                        <a:rPr sz="1300" b="0">
+                          <a:solidFill>
+                            <a:srgbClr val="1F2328"/>
+                          </a:solidFill>
+                          <a:latin typeface="Calibri"/>
+                        </a:rPr>
+                        <a:t>да</a:t>
+                      </a:r>
+                    </a:p>
+                  </a:txBody>
+                  <a:tcPr marL="73152" marR="73152" marT="27432" marB="27432" anchor="ctr">
+                    <a:solidFill>
+                      <a:srgbClr val="FFFFFF"/>
+                    </a:solidFill>
+                  </a:tcPr>
+                </a:tc>
+              </a:tr>
+              <a:tr h="384048">
+                <a:tc>
+                  <a:txBody>
+                    <a:bodyPr/>
+                    <a:lstStyle/>
+                    <a:p>
+                      <a:pPr algn="l"/>
+                      <a:r>
+                        <a:rPr sz="1300" b="0">
+                          <a:solidFill>
+                            <a:srgbClr val="1F2328"/>
+                          </a:solidFill>
+                          <a:latin typeface="Calibri"/>
+                        </a:rPr>
+                        <a:t>Рёбер</a:t>
+                      </a:r>
+                    </a:p>
+                  </a:txBody>
+                  <a:tcPr marL="73152" marR="73152" marT="27432" marB="27432" anchor="ctr">
+                    <a:solidFill>
+                      <a:srgbClr val="FFFFFF"/>
+                    </a:solidFill>
+                  </a:tcPr>
+                </a:tc>
+                <a:tc>
+                  <a:txBody>
+                    <a:bodyPr/>
+                    <a:lstStyle/>
+                    <a:p>
+                      <a:pPr algn="l"/>
+                      <a:r>
+                        <a:rPr sz="1300" b="0">
+                          <a:solidFill>
+                            <a:srgbClr val="1F2328"/>
+                          </a:solidFill>
+                          <a:latin typeface="Calibri"/>
+                        </a:rPr>
+                        <a:t>437</a:t>
+                      </a:r>
+                    </a:p>
+                  </a:txBody>
+                  <a:tcPr marL="73152" marR="73152" marT="27432" marB="27432" anchor="ctr">
+                    <a:solidFill>
+                      <a:srgbClr val="FFFFFF"/>
+                    </a:solidFill>
+                  </a:tcPr>
+                </a:tc>
+                <a:tc>
+                  <a:txBody>
+                    <a:bodyPr/>
+                    <a:lstStyle/>
+                    <a:p>
+                      <a:pPr algn="l"/>
+                      <a:r>
+                        <a:rPr sz="1300" b="0">
+                          <a:solidFill>
+                            <a:srgbClr val="1F2328"/>
+                          </a:solidFill>
+                          <a:latin typeface="Calibri"/>
+                        </a:rPr>
+                        <a:t>433</a:t>
+                      </a:r>
+                    </a:p>
+                  </a:txBody>
+                  <a:tcPr marL="73152" marR="73152" marT="27432" marB="27432" anchor="ctr">
+                    <a:solidFill>
+                      <a:srgbClr val="FFFFFF"/>
+                    </a:solidFill>
+                  </a:tcPr>
+                </a:tc>
+                <a:tc>
+                  <a:txBody>
+                    <a:bodyPr/>
+                    <a:lstStyle/>
+                    <a:p>
+                      <a:pPr algn="r"/>
+                      <a:r>
+                        <a:rPr sz="1300" b="0">
+                          <a:solidFill>
+                            <a:srgbClr val="2A78D6"/>
+                          </a:solidFill>
+                          <a:latin typeface="Calibri"/>
+                        </a:rPr>
+                        <a:t>455</a:t>
+                      </a:r>
+                    </a:p>
+                  </a:txBody>
+                  <a:tcPr marL="73152" marR="73152" marT="27432" marB="27432" anchor="ctr">
+                    <a:solidFill>
+                      <a:srgbClr val="FFFFFF"/>
+                    </a:solidFill>
+                  </a:tcPr>
+                </a:tc>
+                <a:tc>
+                  <a:txBody>
+                    <a:bodyPr/>
+                    <a:lstStyle/>
+                    <a:p>
+                      <a:pPr algn="l"/>
+                      <a:r>
+                        <a:rPr sz="1300" b="0">
+                          <a:solidFill>
+                            <a:srgbClr val="1F2328"/>
+                          </a:solidFill>
+                          <a:latin typeface="Calibri"/>
+                        </a:rPr>
+                        <a:t/>
+                      </a:r>
+                    </a:p>
+                  </a:txBody>
+                  <a:tcPr marL="73152" marR="73152" marT="27432" marB="27432" anchor="ctr">
+                    <a:solidFill>
+                      <a:srgbClr val="FFFFFF"/>
+                    </a:solidFill>
+                  </a:tcPr>
+                </a:tc>
+              </a:tr>
+              <a:tr h="384048">
+                <a:tc>
+                  <a:txBody>
+                    <a:bodyPr/>
+                    <a:lstStyle/>
+                    <a:p>
+                      <a:pPr algn="l"/>
+                      <a:r>
+                        <a:rPr sz="1300" b="0">
+                          <a:solidFill>
+                            <a:srgbClr val="1F2328"/>
+                          </a:solidFill>
+                          <a:latin typeface="Calibri"/>
+                        </a:rPr>
+                        <a:t>Компонент связности</a:t>
+                      </a:r>
+                    </a:p>
+                  </a:txBody>
+                  <a:tcPr marL="73152" marR="73152" marT="27432" marB="27432" anchor="ctr">
+                    <a:solidFill>
+                      <a:srgbClr val="FFFFFF"/>
+                    </a:solidFill>
+                  </a:tcPr>
+                </a:tc>
+                <a:tc>
+                  <a:txBody>
+                    <a:bodyPr/>
+                    <a:lstStyle/>
+                    <a:p>
+                      <a:pPr algn="l"/>
+                      <a:r>
+                        <a:rPr sz="1300" b="0">
+                          <a:solidFill>
+                            <a:srgbClr val="1F2328"/>
+                          </a:solidFill>
+                          <a:latin typeface="Calibri"/>
+                        </a:rPr>
+                        <a:t>84</a:t>
+                      </a:r>
+                    </a:p>
+                  </a:txBody>
+                  <a:tcPr marL="73152" marR="73152" marT="27432" marB="27432" anchor="ctr">
+                    <a:solidFill>
+                      <a:srgbClr val="FFFFFF"/>
+                    </a:solidFill>
+                  </a:tcPr>
+                </a:tc>
+                <a:tc>
+                  <a:txBody>
+                    <a:bodyPr/>
+                    <a:lstStyle/>
+                    <a:p>
+                      <a:pPr algn="l"/>
+                      <a:r>
+                        <a:rPr sz="1300" b="0">
+                          <a:solidFill>
+                            <a:srgbClr val="1F2328"/>
+                          </a:solidFill>
+                          <a:latin typeface="Calibri"/>
+                        </a:rPr>
+                        <a:t>67</a:t>
+                      </a:r>
+                    </a:p>
+                  </a:txBody>
+                  <a:tcPr marL="73152" marR="73152" marT="27432" marB="27432" anchor="ctr">
+                    <a:solidFill>
+                      <a:srgbClr val="FFFFFF"/>
+                    </a:solidFill>
+                  </a:tcPr>
+                </a:tc>
+                <a:tc>
+                  <a:txBody>
+                    <a:bodyPr/>
+                    <a:lstStyle/>
+                    <a:p>
+                      <a:pPr algn="r"/>
+                      <a:r>
+                        <a:rPr sz="1300" b="0">
+                          <a:solidFill>
+                            <a:srgbClr val="2A78D6"/>
+                          </a:solidFill>
+                          <a:latin typeface="Calibri"/>
+                        </a:rPr>
+                        <a:t>40</a:t>
+                      </a:r>
+                    </a:p>
+                  </a:txBody>
+                  <a:tcPr marL="73152" marR="73152" marT="27432" marB="27432" anchor="ctr">
+                    <a:solidFill>
+                      <a:srgbClr val="FFFFFF"/>
+                    </a:solidFill>
+                  </a:tcPr>
+                </a:tc>
+                <a:tc>
+                  <a:txBody>
+                    <a:bodyPr/>
+                    <a:lstStyle/>
+                    <a:p>
+                      <a:pPr algn="l"/>
+                      <a:r>
+                        <a:rPr sz="1300" b="0">
+                          <a:solidFill>
+                            <a:srgbClr val="1F2328"/>
+                          </a:solidFill>
+                          <a:latin typeface="Calibri"/>
+                        </a:rPr>
+                        <a:t>да</a:t>
+                      </a:r>
+                    </a:p>
+                  </a:txBody>
+                  <a:tcPr marL="73152" marR="73152" marT="27432" marB="27432" anchor="ctr">
+                    <a:solidFill>
+                      <a:srgbClr val="FFFFFF"/>
+                    </a:solidFill>
+                  </a:tcPr>
+                </a:tc>
+              </a:tr>
+              <a:tr h="384048">
+                <a:tc>
+                  <a:txBody>
+                    <a:bodyPr/>
+                    <a:lstStyle/>
+                    <a:p>
+                      <a:pPr algn="l"/>
+                      <a:r>
+                        <a:rPr sz="1300" b="0">
+                          <a:solidFill>
+                            <a:srgbClr val="1F2328"/>
+                          </a:solidFill>
+                          <a:latin typeface="Calibri"/>
+                        </a:rPr>
+                        <a:t>Крупнейшая компонента</a:t>
+                      </a:r>
+                    </a:p>
+                  </a:txBody>
+                  <a:tcPr marL="73152" marR="73152" marT="27432" marB="27432" anchor="ctr">
+                    <a:solidFill>
+                      <a:srgbClr val="FFFFFF"/>
+                    </a:solidFill>
+                  </a:tcPr>
+                </a:tc>
+                <a:tc>
+                  <a:txBody>
+                    <a:bodyPr/>
+                    <a:lstStyle/>
+                    <a:p>
+                      <a:pPr algn="l"/>
+                      <a:r>
+                        <a:rPr sz="1300" b="0">
+                          <a:solidFill>
+                            <a:srgbClr val="1F2328"/>
+                          </a:solidFill>
+                          <a:latin typeface="Calibri"/>
+                        </a:rPr>
+                        <a:t>66,0%</a:t>
+                      </a:r>
+                    </a:p>
+                  </a:txBody>
+                  <a:tcPr marL="73152" marR="73152" marT="27432" marB="27432" anchor="ctr">
+                    <a:solidFill>
+                      <a:srgbClr val="FFFFFF"/>
+                    </a:solidFill>
+                  </a:tcPr>
+                </a:tc>
+                <a:tc>
+                  <a:txBody>
+                    <a:bodyPr/>
+                    <a:lstStyle/>
+                    <a:p>
+                      <a:pPr algn="l"/>
+                      <a:r>
+                        <a:rPr sz="1300" b="0">
+                          <a:solidFill>
+                            <a:srgbClr val="1F2328"/>
+                          </a:solidFill>
+                          <a:latin typeface="Calibri"/>
+                        </a:rPr>
+                        <a:t>62,7%</a:t>
+                      </a:r>
+                    </a:p>
+                  </a:txBody>
+                  <a:tcPr marL="73152" marR="73152" marT="27432" marB="27432" anchor="ctr">
+                    <a:solidFill>
+                      <a:srgbClr val="FFFFFF"/>
+                    </a:solidFill>
+                  </a:tcPr>
+                </a:tc>
+                <a:tc>
+                  <a:txBody>
+                    <a:bodyPr/>
+                    <a:lstStyle/>
+                    <a:p>
+                      <a:pPr algn="r"/>
+                      <a:r>
+                        <a:rPr sz="1300" b="0">
+                          <a:solidFill>
+                            <a:srgbClr val="2A78D6"/>
+                          </a:solidFill>
+                          <a:latin typeface="Calibri"/>
+                        </a:rPr>
+                        <a:t>77,2%</a:t>
+                      </a:r>
+                    </a:p>
+                  </a:txBody>
+                  <a:tcPr marL="73152" marR="73152" marT="27432" marB="27432" anchor="ctr">
+                    <a:solidFill>
+                      <a:srgbClr val="FFFFFF"/>
+                    </a:solidFill>
+                  </a:tcPr>
+                </a:tc>
+                <a:tc>
+                  <a:txBody>
+                    <a:bodyPr/>
+                    <a:lstStyle/>
+                    <a:p>
+                      <a:pPr algn="l"/>
+                      <a:r>
+                        <a:rPr sz="1300" b="0">
+                          <a:solidFill>
+                            <a:srgbClr val="1F2328"/>
+                          </a:solidFill>
+                          <a:latin typeface="Calibri"/>
+                        </a:rPr>
+                        <a:t>да</a:t>
+                      </a:r>
+                    </a:p>
+                  </a:txBody>
+                  <a:tcPr marL="73152" marR="73152" marT="27432" marB="27432" anchor="ctr">
+                    <a:solidFill>
+                      <a:srgbClr val="FFFFFF"/>
+                    </a:solidFill>
+                  </a:tcPr>
+                </a:tc>
+              </a:tr>
+              <a:tr h="384048">
+                <a:tc>
+                  <a:txBody>
+                    <a:bodyPr/>
+                    <a:lstStyle/>
+                    <a:p>
+                      <a:pPr algn="l"/>
+                      <a:r>
+                        <a:rPr sz="1300" b="0">
+                          <a:solidFill>
+                            <a:srgbClr val="1F2328"/>
+                          </a:solidFill>
+                          <a:latin typeface="Calibri"/>
+                        </a:rPr>
+                        <a:t>Русских вершин в ней</a:t>
+                      </a:r>
+                    </a:p>
+                  </a:txBody>
+                  <a:tcPr marL="73152" marR="73152" marT="27432" marB="27432" anchor="ctr">
+                    <a:solidFill>
+                      <a:srgbClr val="FFFFFF"/>
+                    </a:solidFill>
+                  </a:tcPr>
+                </a:tc>
+                <a:tc>
+                  <a:txBody>
+                    <a:bodyPr/>
+                    <a:lstStyle/>
+                    <a:p>
+                      <a:pPr algn="l"/>
+                      <a:r>
+                        <a:rPr sz="1300" b="0">
+                          <a:solidFill>
+                            <a:srgbClr val="1F2328"/>
+                          </a:solidFill>
+                          <a:latin typeface="Calibri"/>
+                        </a:rPr>
+                        <a:t>21</a:t>
+                      </a:r>
+                    </a:p>
+                  </a:txBody>
+                  <a:tcPr marL="73152" marR="73152" marT="27432" marB="27432" anchor="ctr">
+                    <a:solidFill>
+                      <a:srgbClr val="FFFFFF"/>
+                    </a:solidFill>
+                  </a:tcPr>
+                </a:tc>
+                <a:tc>
+                  <a:txBody>
+                    <a:bodyPr/>
+                    <a:lstStyle/>
+                    <a:p>
+                      <a:pPr algn="l"/>
+                      <a:r>
+                        <a:rPr sz="1300" b="0">
+                          <a:solidFill>
+                            <a:srgbClr val="1F2328"/>
+                          </a:solidFill>
+                          <a:latin typeface="Calibri"/>
+                        </a:rPr>
+                        <a:t>16</a:t>
+                      </a:r>
+                    </a:p>
+                  </a:txBody>
+                  <a:tcPr marL="73152" marR="73152" marT="27432" marB="27432" anchor="ctr">
+                    <a:solidFill>
+                      <a:srgbClr val="FFFFFF"/>
+                    </a:solidFill>
+                  </a:tcPr>
+                </a:tc>
+                <a:tc>
+                  <a:txBody>
+                    <a:bodyPr/>
+                    <a:lstStyle/>
+                    <a:p>
+                      <a:pPr algn="r"/>
+                      <a:r>
+                        <a:rPr sz="1300" b="0">
+                          <a:solidFill>
+                            <a:srgbClr val="2A78D6"/>
+                          </a:solidFill>
+                          <a:latin typeface="Calibri"/>
+                        </a:rPr>
+                        <a:t>49</a:t>
+                      </a:r>
+                    </a:p>
+                  </a:txBody>
+                  <a:tcPr marL="73152" marR="73152" marT="27432" marB="27432" anchor="ctr">
+                    <a:solidFill>
+                      <a:srgbClr val="FFFFFF"/>
+                    </a:solidFill>
+                  </a:tcPr>
+                </a:tc>
+                <a:tc>
+                  <a:txBody>
+                    <a:bodyPr/>
+                    <a:lstStyle/>
+                    <a:p>
+                      <a:pPr algn="l"/>
+                      <a:r>
+                        <a:rPr sz="1300" b="0">
+                          <a:solidFill>
+                            <a:srgbClr val="1F2328"/>
+                          </a:solidFill>
+                          <a:latin typeface="Calibri"/>
+                        </a:rPr>
+                        <a:t>да</a:t>
+                      </a:r>
+                    </a:p>
+                  </a:txBody>
+                  <a:tcPr marL="73152" marR="73152" marT="27432" marB="27432" anchor="ctr">
+                    <a:solidFill>
+                      <a:srgbClr val="FFFFFF"/>
+                    </a:solidFill>
+                  </a:tcPr>
+                </a:tc>
+              </a:tr>
+              <a:tr h="384048">
+                <a:tc>
+                  <a:txBody>
+                    <a:bodyPr/>
+                    <a:lstStyle/>
+                    <a:p>
+                      <a:pPr algn="l"/>
+                      <a:r>
+                        <a:rPr sz="1300" b="0">
+                          <a:solidFill>
+                            <a:srgbClr val="1F2328"/>
+                          </a:solidFill>
+                          <a:latin typeface="Calibri"/>
+                        </a:rPr>
+                        <a:t>Циклов на 100 вершин</a:t>
+                      </a:r>
+                    </a:p>
+                  </a:txBody>
+                  <a:tcPr marL="73152" marR="73152" marT="27432" marB="27432" anchor="ctr">
+                    <a:solidFill>
+                      <a:srgbClr val="FFFFFF"/>
+                    </a:solidFill>
+                  </a:tcPr>
+                </a:tc>
+                <a:tc>
+                  <a:txBody>
+                    <a:bodyPr/>
+                    <a:lstStyle/>
+                    <a:p>
+                      <a:pPr algn="l"/>
+                      <a:r>
+                        <a:rPr sz="1300" b="0">
+                          <a:solidFill>
+                            <a:srgbClr val="1F2328"/>
+                          </a:solidFill>
+                          <a:latin typeface="Calibri"/>
+                        </a:rPr>
+                        <a:t>22,9</a:t>
+                      </a:r>
+                    </a:p>
+                  </a:txBody>
+                  <a:tcPr marL="73152" marR="73152" marT="27432" marB="27432" anchor="ctr">
+                    <a:solidFill>
+                      <a:srgbClr val="FFFFFF"/>
+                    </a:solidFill>
+                  </a:tcPr>
+                </a:tc>
+                <a:tc>
+                  <a:txBody>
+                    <a:bodyPr/>
+                    <a:lstStyle/>
+                    <a:p>
+                      <a:pPr algn="l"/>
+                      <a:r>
+                        <a:rPr sz="1300" b="0">
+                          <a:solidFill>
+                            <a:srgbClr val="1F2328"/>
+                          </a:solidFill>
+                          <a:latin typeface="Calibri"/>
+                        </a:rPr>
+                        <a:t>28,5</a:t>
+                      </a:r>
+                    </a:p>
+                  </a:txBody>
+                  <a:tcPr marL="73152" marR="73152" marT="27432" marB="27432" anchor="ctr">
+                    <a:solidFill>
+                      <a:srgbClr val="FFFFFF"/>
+                    </a:solidFill>
+                  </a:tcPr>
+                </a:tc>
+                <a:tc>
+                  <a:txBody>
+                    <a:bodyPr/>
+                    <a:lstStyle/>
+                    <a:p>
+                      <a:pPr algn="r"/>
+                      <a:r>
+                        <a:rPr sz="1300" b="0">
+                          <a:solidFill>
+                            <a:srgbClr val="2A78D6"/>
+                          </a:solidFill>
+                          <a:latin typeface="Calibri"/>
+                        </a:rPr>
+                        <a:t>43,1</a:t>
+                      </a:r>
+                    </a:p>
+                  </a:txBody>
+                  <a:tcPr marL="73152" marR="73152" marT="27432" marB="27432" anchor="ctr">
+                    <a:solidFill>
+                      <a:srgbClr val="FFFFFF"/>
+                    </a:solidFill>
+                  </a:tcPr>
+                </a:tc>
+                <a:tc>
+                  <a:txBody>
+                    <a:bodyPr/>
+                    <a:lstStyle/>
+                    <a:p>
+                      <a:pPr algn="l"/>
+                      <a:r>
+                        <a:rPr sz="1300" b="0">
+                          <a:solidFill>
+                            <a:srgbClr val="1F2328"/>
+                          </a:solidFill>
+                          <a:latin typeface="Calibri"/>
+                        </a:rPr>
+                        <a:t>да</a:t>
+                      </a:r>
+                    </a:p>
+                  </a:txBody>
+                  <a:tcPr marL="73152" marR="73152" marT="27432" marB="27432" anchor="ctr">
+                    <a:solidFill>
+                      <a:srgbClr val="FFFFFF"/>
+                    </a:solidFill>
+                  </a:tcPr>
+                </a:tc>
+              </a:tr>
+              <a:tr h="384048">
+                <a:tc>
+                  <a:txBody>
+                    <a:bodyPr/>
+                    <a:lstStyle/>
+                    <a:p>
+                      <a:pPr algn="l"/>
+                      <a:r>
+                        <a:rPr sz="1300" b="0">
+                          <a:solidFill>
+                            <a:srgbClr val="1F2328"/>
+                          </a:solidFill>
+                          <a:latin typeface="Calibri"/>
+                        </a:rPr>
+                        <a:t>Полнота по тексту</a:t>
+                      </a:r>
+                    </a:p>
+                  </a:txBody>
+                  <a:tcPr marL="73152" marR="73152" marT="27432" marB="27432" anchor="ctr">
+                    <a:solidFill>
+                      <a:srgbClr val="FFFFFF"/>
+                    </a:solidFill>
+                  </a:tcPr>
+                </a:tc>
+                <a:tc>
+                  <a:txBody>
+                    <a:bodyPr/>
+                    <a:lstStyle/>
+                    <a:p>
+                      <a:pPr algn="l"/>
+                      <a:r>
+                        <a:rPr sz="1300" b="0">
+                          <a:solidFill>
+                            <a:srgbClr val="1F2328"/>
+                          </a:solidFill>
+                          <a:latin typeface="Calibri"/>
+                        </a:rPr>
+                        <a:t>65,6%</a:t>
+                      </a:r>
+                    </a:p>
+                  </a:txBody>
+                  <a:tcPr marL="73152" marR="73152" marT="27432" marB="27432" anchor="ctr">
+                    <a:solidFill>
+                      <a:srgbClr val="FFFFFF"/>
+                    </a:solidFill>
+                  </a:tcPr>
+                </a:tc>
+                <a:tc>
+                  <a:txBody>
+                    <a:bodyPr/>
+                    <a:lstStyle/>
+                    <a:p>
+                      <a:pPr algn="l"/>
+                      <a:r>
+                        <a:rPr sz="1300" b="0">
+                          <a:solidFill>
+                            <a:srgbClr val="1F2328"/>
+                          </a:solidFill>
+                          <a:latin typeface="Calibri"/>
+                        </a:rPr>
+                        <a:t>67,2%</a:t>
+                      </a:r>
+                    </a:p>
+                  </a:txBody>
+                  <a:tcPr marL="73152" marR="73152" marT="27432" marB="27432" anchor="ctr">
+                    <a:solidFill>
+                      <a:srgbClr val="FFFFFF"/>
+                    </a:solidFill>
+                  </a:tcPr>
+                </a:tc>
+                <a:tc>
+                  <a:txBody>
+                    <a:bodyPr/>
+                    <a:lstStyle/>
+                    <a:p>
+                      <a:pPr algn="r"/>
+                      <a:r>
+                        <a:rPr sz="1300" b="0">
+                          <a:solidFill>
+                            <a:srgbClr val="2A78D6"/>
+                          </a:solidFill>
+                          <a:latin typeface="Calibri"/>
+                        </a:rPr>
+                        <a:t>59,4%</a:t>
+                      </a:r>
+                    </a:p>
+                  </a:txBody>
+                  <a:tcPr marL="73152" marR="73152" marT="27432" marB="27432" anchor="ctr">
+                    <a:solidFill>
+                      <a:srgbClr val="FFFFFF"/>
+                    </a:solidFill>
+                  </a:tcPr>
+                </a:tc>
+                <a:tc>
+                  <a:txBody>
+                    <a:bodyPr/>
+                    <a:lstStyle/>
+                    <a:p>
+                      <a:pPr algn="l"/>
+                      <a:r>
+                        <a:rPr sz="1300" b="0">
+                          <a:solidFill>
+                            <a:srgbClr val="1F2328"/>
+                          </a:solidFill>
+                          <a:latin typeface="Calibri"/>
+                        </a:rPr>
+                        <a:t>да</a:t>
+                      </a:r>
+                    </a:p>
+                  </a:txBody>
+                  <a:tcPr marL="73152" marR="73152" marT="27432" marB="27432" anchor="ctr">
+                    <a:solidFill>
+                      <a:srgbClr val="FFFFFF"/>
+                    </a:solidFill>
+                  </a:tcPr>
+                </a:tc>
+              </a:tr>
+              <a:tr h="384048">
+                <a:tc>
+                  <a:txBody>
+                    <a:bodyPr/>
+                    <a:lstStyle/>
+                    <a:p>
+                      <a:pPr algn="l"/>
+                      <a:r>
+                        <a:rPr sz="1300" b="0">
+                          <a:solidFill>
+                            <a:srgbClr val="1F2328"/>
+                          </a:solidFill>
+                          <a:latin typeface="Calibri"/>
+                        </a:rPr>
+                        <a:t>Дубликатов форм слова</a:t>
+                      </a:r>
+                    </a:p>
+                  </a:txBody>
+                  <a:tcPr marL="73152" marR="73152" marT="27432" marB="27432" anchor="ctr">
+                    <a:solidFill>
+                      <a:srgbClr val="FFFFFF"/>
+                    </a:solidFill>
+                  </a:tcPr>
+                </a:tc>
+                <a:tc>
+                  <a:txBody>
+                    <a:bodyPr/>
+                    <a:lstStyle/>
+                    <a:p>
+                      <a:pPr algn="l"/>
+                      <a:r>
+                        <a:rPr sz="1300" b="0">
+                          <a:solidFill>
+                            <a:srgbClr val="1F2328"/>
+                          </a:solidFill>
+                          <a:latin typeface="Calibri"/>
+                        </a:rPr>
+                        <a:t>19</a:t>
+                      </a:r>
+                    </a:p>
+                  </a:txBody>
+                  <a:tcPr marL="73152" marR="73152" marT="27432" marB="27432" anchor="ctr">
+                    <a:solidFill>
+                      <a:srgbClr val="FFFFFF"/>
+                    </a:solidFill>
+                  </a:tcPr>
+                </a:tc>
+                <a:tc>
+                  <a:txBody>
+                    <a:bodyPr/>
+                    <a:lstStyle/>
+                    <a:p>
+                      <a:pPr algn="l"/>
+                      <a:r>
+                        <a:rPr sz="1300" b="0">
+                          <a:solidFill>
+                            <a:srgbClr val="1F2328"/>
+                          </a:solidFill>
+                          <a:latin typeface="Calibri"/>
+                        </a:rPr>
+                        <a:t>14</a:t>
+                      </a:r>
+                    </a:p>
+                  </a:txBody>
+                  <a:tcPr marL="73152" marR="73152" marT="27432" marB="27432" anchor="ctr">
+                    <a:solidFill>
+                      <a:srgbClr val="FFFFFF"/>
+                    </a:solidFill>
+                  </a:tcPr>
+                </a:tc>
+                <a:tc>
+                  <a:txBody>
+                    <a:bodyPr/>
+                    <a:lstStyle/>
+                    <a:p>
+                      <a:pPr algn="r"/>
+                      <a:r>
+                        <a:rPr sz="1300" b="0">
+                          <a:solidFill>
+                            <a:srgbClr val="2A78D6"/>
+                          </a:solidFill>
+                          <a:latin typeface="Calibri"/>
+                        </a:rPr>
+                        <a:t>8</a:t>
+                      </a:r>
+                    </a:p>
+                  </a:txBody>
+                  <a:tcPr marL="73152" marR="73152" marT="27432" marB="27432" anchor="ctr">
+                    <a:solidFill>
+                      <a:srgbClr val="FFFFFF"/>
+                    </a:solidFill>
+                  </a:tcPr>
+                </a:tc>
+                <a:tc>
+                  <a:txBody>
+                    <a:bodyPr/>
+                    <a:lstStyle/>
+                    <a:p>
+                      <a:pPr algn="l"/>
+                      <a:r>
+                        <a:rPr sz="1300" b="0">
+                          <a:solidFill>
+                            <a:srgbClr val="1F2328"/>
+                          </a:solidFill>
+                          <a:latin typeface="Calibri"/>
+                        </a:rPr>
+                        <a:t>да</a:t>
+                      </a:r>
+                    </a:p>
+                  </a:txBody>
+                  <a:tcPr marL="73152" marR="73152" marT="27432" marB="27432" anchor="ctr">
+                    <a:solidFill>
+                      <a:srgbClr val="FFFFFF"/>
+                    </a:solidFill>
+                  </a:tcPr>
+                </a:tc>
+              </a:tr>
+              <a:tr h="384048">
+                <a:tc>
+                  <a:txBody>
+                    <a:bodyPr/>
+                    <a:lstStyle/>
+                    <a:p>
+                      <a:pPr algn="l"/>
+                      <a:r>
+                        <a:rPr sz="1300" b="0">
+                          <a:solidFill>
+                            <a:srgbClr val="1F2328"/>
+                          </a:solidFill>
+                          <a:latin typeface="Calibri"/>
+                        </a:rPr>
+                        <a:t>Вершин с противоречиями</a:t>
+                      </a:r>
+                    </a:p>
+                  </a:txBody>
+                  <a:tcPr marL="73152" marR="73152" marT="27432" marB="27432" anchor="ctr">
+                    <a:solidFill>
+                      <a:srgbClr val="FFFFFF"/>
+                    </a:solidFill>
+                  </a:tcPr>
+                </a:tc>
+                <a:tc>
+                  <a:txBody>
+                    <a:bodyPr/>
+                    <a:lstStyle/>
+                    <a:p>
+                      <a:pPr algn="l"/>
+                      <a:r>
+                        <a:rPr sz="1300" b="0">
+                          <a:solidFill>
+                            <a:srgbClr val="1F2328"/>
+                          </a:solidFill>
+                          <a:latin typeface="Calibri"/>
+                        </a:rPr>
+                        <a:t>30,8%</a:t>
+                      </a:r>
+                    </a:p>
+                  </a:txBody>
+                  <a:tcPr marL="73152" marR="73152" marT="27432" marB="27432" anchor="ctr">
+                    <a:solidFill>
+                      <a:srgbClr val="FFFFFF"/>
+                    </a:solidFill>
+                  </a:tcPr>
+                </a:tc>
+                <a:tc>
+                  <a:txBody>
+                    <a:bodyPr/>
+                    <a:lstStyle/>
+                    <a:p>
+                      <a:pPr algn="l"/>
+                      <a:r>
+                        <a:rPr sz="1300" b="0">
+                          <a:solidFill>
+                            <a:srgbClr val="1F2328"/>
+                          </a:solidFill>
+                          <a:latin typeface="Calibri"/>
+                        </a:rPr>
+                        <a:t>28,3%</a:t>
+                      </a:r>
+                    </a:p>
+                  </a:txBody>
+                  <a:tcPr marL="73152" marR="73152" marT="27432" marB="27432" anchor="ctr">
+                    <a:solidFill>
+                      <a:srgbClr val="FFFFFF"/>
+                    </a:solidFill>
+                  </a:tcPr>
+                </a:tc>
+                <a:tc>
+                  <a:txBody>
+                    <a:bodyPr/>
+                    <a:lstStyle/>
+                    <a:p>
+                      <a:pPr algn="r"/>
+                      <a:r>
+                        <a:rPr sz="1300" b="0">
+                          <a:solidFill>
+                            <a:srgbClr val="2A78D6"/>
+                          </a:solidFill>
+                          <a:latin typeface="Calibri"/>
+                        </a:rPr>
+                        <a:t>30,8%</a:t>
+                      </a:r>
+                    </a:p>
+                  </a:txBody>
+                  <a:tcPr marL="73152" marR="73152" marT="27432" marB="27432" anchor="ctr">
+                    <a:solidFill>
+                      <a:srgbClr val="FFFFFF"/>
+                    </a:solidFill>
+                  </a:tcPr>
+                </a:tc>
+                <a:tc>
+                  <a:txBody>
+                    <a:bodyPr/>
+                    <a:lstStyle/>
+                    <a:p>
+                      <a:pPr algn="l"/>
+                      <a:r>
+                        <a:rPr sz="1300" b="0">
+                          <a:solidFill>
+                            <a:srgbClr val="1F2328"/>
+                          </a:solidFill>
+                          <a:latin typeface="Calibri"/>
+                        </a:rPr>
+                        <a:t/>
+                      </a:r>
+                    </a:p>
+                  </a:txBody>
+                  <a:tcPr marL="73152" marR="73152" marT="27432" marB="27432" anchor="ctr">
+                    <a:solidFill>
+                      <a:srgbClr val="FFFFFF"/>
+                    </a:solidFill>
+                  </a:tcPr>
+                </a:tc>
+              </a:tr>
+              <a:tr h="384048">
+                <a:tc>
+                  <a:txBody>
+                    <a:bodyPr/>
+                    <a:lstStyle/>
+                    <a:p>
+                      <a:pPr algn="l"/>
+                      <a:r>
+                        <a:rPr sz="1300" b="0">
+                          <a:solidFill>
+                            <a:srgbClr val="1F2328"/>
+                          </a:solidFill>
+                          <a:latin typeface="Calibri"/>
+                        </a:rPr>
+                        <a:t>MRR поиска по чанкам</a:t>
+                      </a:r>
+                    </a:p>
+                  </a:txBody>
+                  <a:tcPr marL="73152" marR="73152" marT="27432" marB="27432" anchor="ctr">
+                    <a:solidFill>
+                      <a:srgbClr val="FFFFFF"/>
+                    </a:solidFill>
+                  </a:tcPr>
+                </a:tc>
+                <a:tc>
+                  <a:txBody>
+                    <a:bodyPr/>
+                    <a:lstStyle/>
+                    <a:p>
+                      <a:pPr algn="l"/>
+                      <a:r>
+                        <a:rPr sz="1300" b="0">
+                          <a:solidFill>
+                            <a:srgbClr val="1F2328"/>
+                          </a:solidFill>
+                          <a:latin typeface="Calibri"/>
+                        </a:rPr>
+                        <a:t>0,77</a:t>
+                      </a:r>
+                    </a:p>
+                  </a:txBody>
+                  <a:tcPr marL="73152" marR="73152" marT="27432" marB="27432" anchor="ctr">
+                    <a:solidFill>
+                      <a:srgbClr val="FFFFFF"/>
+                    </a:solidFill>
+                  </a:tcPr>
+                </a:tc>
+                <a:tc>
+                  <a:txBody>
+                    <a:bodyPr/>
+                    <a:lstStyle/>
+                    <a:p>
+                      <a:pPr algn="l"/>
+                      <a:r>
+                        <a:rPr sz="1300" b="0">
+                          <a:solidFill>
+                            <a:srgbClr val="1F2328"/>
+                          </a:solidFill>
+                          <a:latin typeface="Calibri"/>
+                        </a:rPr>
+                        <a:t>—</a:t>
+                      </a:r>
+                    </a:p>
+                  </a:txBody>
+                  <a:tcPr marL="73152" marR="73152" marT="27432" marB="27432" anchor="ctr">
+                    <a:solidFill>
+                      <a:srgbClr val="FFFFFF"/>
+                    </a:solidFill>
+                  </a:tcPr>
+                </a:tc>
+                <a:tc>
+                  <a:txBody>
+                    <a:bodyPr/>
+                    <a:lstStyle/>
+                    <a:p>
+                      <a:pPr algn="r"/>
+                      <a:r>
+                        <a:rPr sz="1300" b="0">
+                          <a:solidFill>
+                            <a:srgbClr val="2A78D6"/>
+                          </a:solidFill>
+                          <a:latin typeface="Calibri"/>
+                        </a:rPr>
+                        <a:t>0,73</a:t>
+                      </a:r>
+                    </a:p>
+                  </a:txBody>
+                  <a:tcPr marL="73152" marR="73152" marT="27432" marB="27432" anchor="ctr">
+                    <a:solidFill>
+                      <a:srgbClr val="FFFFFF"/>
+                    </a:solidFill>
+                  </a:tcPr>
+                </a:tc>
+                <a:tc>
+                  <a:txBody>
+                    <a:bodyPr/>
+                    <a:lstStyle/>
+                    <a:p>
+                      <a:pPr algn="l"/>
+                      <a:r>
+                        <a:rPr sz="1300" b="0">
+                          <a:solidFill>
+                            <a:srgbClr val="1F2328"/>
+                          </a:solidFill>
+                          <a:latin typeface="Calibri"/>
+                        </a:rPr>
+                        <a:t/>
+                      </a:r>
+                    </a:p>
+                  </a:txBody>
+                  <a:tcPr marL="73152" marR="73152" marT="27432" marB="27432" anchor="ctr">
+                    <a:solidFill>
+                      <a:srgbClr val="FFFFFF"/>
+                    </a:solidFill>
+                  </a:tcPr>
+                </a:tc>
+              </a:tr>
+            </a:tbl>
+          </a:graphicData>
+        </a:graphic>
+      </p:graphicFrame>
+      <p:sp>
+        <p:nvSpPr>
+          <p:cNvPr id="4" name="TextBox 3"/>
+          <p:cNvSpPr txBox="1"/>
+          <p:nvPr/>
+        </p:nvSpPr>
+        <p:spPr>
+          <a:xfrm>
+            <a:off x="8229600" y="1280160"/>
+            <a:ext cx="3566160" cy="4754880"/>
+          </a:xfrm>
+          <a:prstGeom prst="rect">
+            <a:avLst/>
+          </a:prstGeom>
+          <a:noFill/>
+        </p:spPr>
+        <p:txBody>
+          <a:bodyPr wrap="square" lIns="0" rIns="0" tIns="0" bIns="0">
+            <a:spAutoFit/>
+          </a:bodyPr>
+          <a:lstStyle/>
+          <a:p>
+            <a:pPr algn="l">
+              <a:spcAft>
+                <a:spcPts val="1000"/>
+              </a:spcAft>
+            </a:pPr>
+            <a:r>
+              <a:rPr sz="1400" b="0">
+                <a:solidFill>
+                  <a:srgbClr val="1F2328"/>
+                </a:solidFill>
+                <a:latin typeface="Calibri"/>
+              </a:rPr>
+              <a:t>С чанка — около 15 сущностей при любой длине: пересечение тратит их на повтор соседа</a:t>
+            </a:r>
+          </a:p>
+          <a:p>
+            <a:pPr algn="l">
+              <a:spcAft>
+                <a:spcPts val="1000"/>
+              </a:spcAft>
+            </a:pPr>
+            <a:r>
+              <a:rPr sz="1400" b="0">
+                <a:solidFill>
+                  <a:srgbClr val="1F2328"/>
+                </a:solidFill>
+                <a:latin typeface="Calibri"/>
+              </a:rPr>
+              <a:t>Уникальных вершин меньше, связей больше — граф связнее, русская книга в общей компоненте</a:t>
+            </a:r>
+          </a:p>
+          <a:p>
+            <a:pPr algn="l">
+              <a:spcAft>
+                <a:spcPts val="1000"/>
+              </a:spcAft>
+            </a:pPr>
+            <a:r>
+              <a:rPr sz="1400" b="0">
+                <a:solidFill>
+                  <a:srgbClr val="1F2328"/>
+                </a:solidFill>
+                <a:latin typeface="Calibri"/>
+              </a:rPr>
+              <a:t>70% циклов идут через хаб CONTROLLED ROLLING — рост звёздный (в базе 60%)</a:t>
+            </a:r>
+          </a:p>
+          <a:p>
+            <a:pPr algn="l">
+              <a:spcAft>
+                <a:spcPts val="1000"/>
+              </a:spcAft>
+            </a:pPr>
+            <a:r>
+              <a:rPr sz="1400" b="0">
+                <a:solidFill>
+                  <a:srgbClr val="1F2328"/>
+                </a:solidFill>
+                <a:latin typeface="Calibri"/>
+              </a:rPr>
+              <a:t>Полнота и поиск хуже: соседние чанки стали похожи, редкие факты тонут</a:t>
+            </a:r>
+          </a:p>
+          <a:p>
+            <a:pPr algn="l">
+              <a:spcAft>
+                <a:spcPts val="1000"/>
+              </a:spcAft>
+            </a:pPr>
+            <a:r>
+              <a:rPr sz="1400" b="0">
+                <a:solidFill>
+                  <a:srgbClr val="1F2328"/>
+                </a:solidFill>
+                <a:latin typeface="Calibri"/>
+              </a:rPr>
+              <a:t>Вывод: пересечение — компромисс; для RAG оставляем чанки без пересечения</a:t>
+            </a:r>
+          </a:p>
+        </p:txBody>
+      </p:sp>
+      <p:sp>
+        <p:nvSpPr>
+          <p:cNvPr id="5" name="TextBox 4"/>
+          <p:cNvSpPr txBox="1"/>
+          <p:nvPr/>
+        </p:nvSpPr>
+        <p:spPr>
+          <a:xfrm>
+            <a:off x="548640" y="6263640"/>
+            <a:ext cx="11064240" cy="365760"/>
+          </a:xfrm>
+          <a:prstGeom prst="rect">
+            <a:avLst/>
+          </a:prstGeom>
+          <a:noFill/>
+        </p:spPr>
+        <p:txBody>
+          <a:bodyPr wrap="square" lIns="0" rIns="0" tIns="0" bIns="0">
+            <a:spAutoFit/>
+          </a:bodyPr>
+          <a:lstStyle/>
+          <a:p>
+            <a:pPr algn="l">
+              <a:spcAft>
+                <a:spcPts val="600"/>
+              </a:spcAft>
+            </a:pPr>
+            <a:r>
+              <a:rPr sz="1200" b="0">
+                <a:solidFill>
+                  <a:srgbClr val="5F5E5A"/>
+                </a:solidFill>
+                <a:latin typeface="Calibri"/>
+              </a:rPr>
+              <a:t>повтор — тот же вход, проиндексированный второй раз, показывает шум GraphRAG; «явно» — отклонение больше удвоенного шума</a:t>
+            </a:r>
+          </a:p>
+        </p:txBody>
+      </p:sp>
+      <p:sp>
+        <p:nvSpPr>
+          <p:cNvPr id="6" name="TextBox 5"/>
+          <p:cNvSpPr txBox="1"/>
+          <p:nvPr/>
+        </p:nvSpPr>
+        <p:spPr>
+          <a:xfrm>
+            <a:off x="10725912" y="6528816"/>
+            <a:ext cx="914400" cy="237744"/>
+          </a:xfrm>
+          <a:prstGeom prst="rect">
+            <a:avLst/>
+          </a:prstGeom>
+          <a:noFill/>
+        </p:spPr>
+        <p:txBody>
+          <a:bodyPr wrap="square" lIns="0" rIns="0" tIns="0" bIns="0">
+            <a:spAutoFit/>
+          </a:bodyPr>
+          <a:lstStyle/>
+          <a:p>
+            <a:pPr algn="r">
+              <a:spcAft>
+                <a:spcPts val="600"/>
+              </a:spcAft>
+            </a:pPr>
+            <a:r>
+              <a:rPr sz="1100" b="0">
+                <a:solidFill>
+                  <a:srgbClr val="5F5E5A"/>
+                </a:solidFill>
+                <a:latin typeface="Calibri"/>
+              </a:rPr>
+              <a:t>4 / 4</a:t>
             </a:r>
           </a:p>
         </p:txBody>

</xml_diff>

<commit_message>
lab-2: drop the judge-choice slide and its rework.md section
Co-Authored-By: Claude Opus 5.5 <noreply@anthropic.com>
</commit_message>
<xml_diff>
--- a/1-graph/lab-2/results/rework_2026-10-12.pptx
+++ b/1-graph/lab-2/results/rework_2026-10-12.pptx
@@ -8,7 +8,6 @@
     <p:sldId id="256" r:id="rId7"/>
     <p:sldId id="257" r:id="rId9"/>
     <p:sldId id="258" r:id="rId10"/>
-    <p:sldId id="259" r:id="rId11"/>
   </p:sldIdLst>
   <p:sldSz cx="12191695" cy="6858000" type="screen4x3"/>
   <p:notesSz cx="6858000" cy="9144000"/>
@@ -1201,76 +1200,6 @@
 </file>
 
 <file path=ppt/notesSlides/notesSlide3.xml><?xml version="1.0" encoding="utf-8"?>
-<p:notes xmlns:a="http://schemas.openxmlformats.org/drawingml/2006/main" xmlns:p="http://schemas.openxmlformats.org/presentationml/2006/main" xmlns:r="http://schemas.openxmlformats.org/officeDocument/2006/relationships">
-  <p:cSld>
-    <p:spTree>
-      <p:nvGrpSpPr>
-        <p:cNvPr id="1" name=""/>
-        <p:cNvGrpSpPr/>
-        <p:nvPr/>
-      </p:nvGrpSpPr>
-      <p:grpSpPr>
-        <a:xfrm>
-          <a:off x="0" y="0"/>
-          <a:ext cx="0" cy="0"/>
-          <a:chOff x="0" y="0"/>
-          <a:chExt cx="0" cy="0"/>
-        </a:xfrm>
-      </p:grpSpPr>
-      <p:sp>
-        <p:nvSpPr>
-          <p:cNvPr id="2" name="Slide Image Placeholder 1"/>
-          <p:cNvSpPr>
-            <a:spLocks noGrp="1"/>
-          </p:cNvSpPr>
-          <p:nvPr>
-            <p:ph type="sldImg" idx="2"/>
-          </p:nvPr>
-        </p:nvSpPr>
-        <p:spPr/>
-      </p:sp>
-      <p:sp>
-        <p:nvSpPr>
-          <p:cNvPr id="3" name="Notes Placeholder 2"/>
-          <p:cNvSpPr>
-            <a:spLocks noGrp="1"/>
-          </p:cNvSpPr>
-          <p:nvPr>
-            <p:ph type="body" idx="3" sz="quarter"/>
-          </p:nvPr>
-        </p:nvSpPr>
-        <p:spPr/>
-        <p:txBody>
-          <a:bodyPr/>
-          <a:lstStyle/>
-          <a:p>
-            <a:r>
-              <a:t>Те же 120 вершин каждого графа оценили gpt-4.1 дважды и три локальные модели через Ollama. Больше — не лучше: Qwen2.5-32B согласна с gpt-4.1 хуже, чем 14B, а на грязном графе находит вдвое меньше противоречий. Gemma3-12B не нашла ни одного. Локальные модели детерминированы — повтор Qwen-14B совпал один в один, — но обе Qwen считают чистый граф хуже грязного: это систематический сдвиг, а не шум. 25 вершин, где gpt-4.1 и обе Qwen расходятся, разметили вслепую по тексту: ни один судья там не надёжен, gpt-4.1 чуть точнее. С поправкой на разметку gpt-4.1 даёт 39,5% → 31,0% — направление то же. Оставляем судьёй gpt-4.1; разница графов по непротиворечивости — на границе точности судьи.</a:t>
-            </a:r>
-          </a:p>
-        </p:txBody>
-      </p:sp>
-      <p:sp>
-        <p:nvSpPr>
-          <p:cNvPr id="4" name="Slide Number Placeholder 3"/>
-          <p:cNvSpPr>
-            <a:spLocks noGrp="1"/>
-          </p:cNvSpPr>
-          <p:nvPr>
-            <p:ph type="sldNum" idx="5" sz="quarter"/>
-          </p:nvPr>
-        </p:nvSpPr>
-        <p:spPr/>
-      </p:sp>
-    </p:spTree>
-  </p:cSld>
-  <p:clrMapOvr>
-    <a:masterClrMapping/>
-  </p:clrMapOvr>
-</p:notes>
-</file>
-
-<file path=ppt/notesSlides/notesSlide4.xml><?xml version="1.0" encoding="utf-8"?>
 <p:notes xmlns:a="http://schemas.openxmlformats.org/drawingml/2006/main" xmlns:p="http://schemas.openxmlformats.org/presentationml/2006/main" xmlns:r="http://schemas.openxmlformats.org/officeDocument/2006/relationships">
   <p:cSld>
     <p:spTree>
@@ -4837,7 +4766,7 @@
                 </a:solidFill>
                 <a:latin typeface="Calibri"/>
               </a:rPr>
-              <a:t>1 / 4</a:t>
+              <a:t>1 / 3</a:t>
             </a:r>
           </a:p>
         </p:txBody>
@@ -5040,7 +4969,7 @@
                 </a:solidFill>
                 <a:latin typeface="Calibri"/>
               </a:rPr>
-              <a:t>2 / 4</a:t>
+              <a:t>2 / 3</a:t>
             </a:r>
           </a:p>
         </p:txBody>
@@ -5054,842 +4983,6 @@
 </file>
 
 <file path=ppt/slides/slide3.xml><?xml version="1.0" encoding="utf-8"?>
-<p:sld xmlns:a="http://schemas.openxmlformats.org/drawingml/2006/main" xmlns:p="http://schemas.openxmlformats.org/presentationml/2006/main" xmlns:r="http://schemas.openxmlformats.org/officeDocument/2006/relationships">
-  <p:cSld>
-    <p:spTree>
-      <p:nvGrpSpPr>
-        <p:cNvPr id="1" name=""/>
-        <p:cNvGrpSpPr/>
-        <p:nvPr/>
-      </p:nvGrpSpPr>
-      <p:grpSpPr/>
-      <p:sp>
-        <p:nvSpPr>
-          <p:cNvPr id="2" name="TextBox 1"/>
-          <p:cNvSpPr txBox="1"/>
-          <p:nvPr/>
-        </p:nvSpPr>
-        <p:spPr>
-          <a:xfrm>
-            <a:off x="548640" y="411480"/>
-            <a:ext cx="11064240" cy="731520"/>
-          </a:xfrm>
-          <a:prstGeom prst="rect">
-            <a:avLst/>
-          </a:prstGeom>
-          <a:noFill/>
-        </p:spPr>
-        <p:txBody>
-          <a:bodyPr wrap="square" lIns="0" rIns="0" tIns="0" bIns="0">
-            <a:spAutoFit/>
-          </a:bodyPr>
-          <a:lstStyle/>
-          <a:p>
-            <a:pPr algn="l">
-              <a:spcAft>
-                <a:spcPts val="600"/>
-              </a:spcAft>
-            </a:pPr>
-            <a:r>
-              <a:rPr sz="2800" b="1">
-                <a:solidFill>
-                  <a:srgbClr val="1F2328"/>
-                </a:solidFill>
-                <a:latin typeface="Calibri"/>
-              </a:rPr>
-              <a:t>Какой судья: gpt-4.1 или локальная модель</a:t>
-            </a:r>
-          </a:p>
-        </p:txBody>
-      </p:sp>
-      <p:graphicFrame>
-        <p:nvGraphicFramePr>
-          <p:cNvPr id="3" name="Table 2"/>
-          <p:cNvGraphicFramePr>
-            <a:graphicFrameLocks noGrp="1"/>
-          </p:cNvGraphicFramePr>
-          <p:nvPr/>
-        </p:nvGraphicFramePr>
-        <p:xfrm>
-          <a:off x="548640" y="1280160"/>
-          <a:ext cx="11064240" cy="2286000"/>
-        </p:xfrm>
-        <a:graphic>
-          <a:graphicData uri="http://schemas.openxmlformats.org/drawingml/2006/table">
-            <a:tbl>
-              <a:tblPr firstRow="1" bandRow="1">
-                <a:tableStyleId>{5C22544A-7EE6-4342-B048-85BDC9FD1C3A}</a:tableStyleId>
-              </a:tblPr>
-              <a:tblGrid>
-                <a:gridCol w="2377440"/>
-                <a:gridCol w="2743200"/>
-                <a:gridCol w="2377440"/>
-                <a:gridCol w="1828800"/>
-                <a:gridCol w="1737360"/>
-              </a:tblGrid>
-              <a:tr h="457200">
-                <a:tc>
-                  <a:txBody>
-                    <a:bodyPr/>
-                    <a:lstStyle/>
-                    <a:p>
-                      <a:pPr algn="l"/>
-                      <a:r>
-                        <a:rPr sz="1400" b="1">
-                          <a:solidFill>
-                            <a:srgbClr val="5F5E5A"/>
-                          </a:solidFill>
-                          <a:latin typeface="Calibri"/>
-                        </a:rPr>
-                        <a:t>Судья</a:t>
-                      </a:r>
-                    </a:p>
-                  </a:txBody>
-                  <a:tcPr marL="73152" marR="73152" marT="27432" marB="27432" anchor="ctr">
-                    <a:solidFill>
-                      <a:srgbClr val="F1F4F8"/>
-                    </a:solidFill>
-                  </a:tcPr>
-                </a:tc>
-                <a:tc>
-                  <a:txBody>
-                    <a:bodyPr/>
-                    <a:lstStyle/>
-                    <a:p>
-                      <a:pPr algn="r"/>
-                      <a:r>
-                        <a:rPr sz="1400" b="1">
-                          <a:solidFill>
-                            <a:srgbClr val="5F5E5A"/>
-                          </a:solidFill>
-                          <a:latin typeface="Calibri"/>
-                        </a:rPr>
-                        <a:t>Противоречий</a:t>
-                      </a:r>
-                    </a:p>
-                  </a:txBody>
-                  <a:tcPr marL="73152" marR="73152" marT="27432" marB="27432" anchor="ctr">
-                    <a:solidFill>
-                      <a:srgbClr val="F1F4F8"/>
-                    </a:solidFill>
-                  </a:tcPr>
-                </a:tc>
-                <a:tc>
-                  <a:txBody>
-                    <a:bodyPr/>
-                    <a:lstStyle/>
-                    <a:p>
-                      <a:pPr algn="l"/>
-                      <a:r>
-                        <a:rPr sz="1400" b="1">
-                          <a:solidFill>
-                            <a:srgbClr val="5F5E5A"/>
-                          </a:solidFill>
-                          <a:latin typeface="Calibri"/>
-                        </a:rPr>
-                        <a:t>κ с gpt-4.1</a:t>
-                      </a:r>
-                    </a:p>
-                  </a:txBody>
-                  <a:tcPr marL="73152" marR="73152" marT="27432" marB="27432" anchor="ctr">
-                    <a:solidFill>
-                      <a:srgbClr val="F1F4F8"/>
-                    </a:solidFill>
-                  </a:tcPr>
-                </a:tc>
-                <a:tc>
-                  <a:txBody>
-                    <a:bodyPr/>
-                    <a:lstStyle/>
-                    <a:p>
-                      <a:pPr algn="l"/>
-                      <a:r>
-                        <a:rPr sz="1400" b="1">
-                          <a:solidFill>
-                            <a:srgbClr val="5F5E5A"/>
-                          </a:solidFill>
-                          <a:latin typeface="Calibri"/>
-                        </a:rPr>
-                        <a:t>Повтор, κ</a:t>
-                      </a:r>
-                    </a:p>
-                  </a:txBody>
-                  <a:tcPr marL="73152" marR="73152" marT="27432" marB="27432" anchor="ctr">
-                    <a:solidFill>
-                      <a:srgbClr val="F1F4F8"/>
-                    </a:solidFill>
-                  </a:tcPr>
-                </a:tc>
-                <a:tc>
-                  <a:txBody>
-                    <a:bodyPr/>
-                    <a:lstStyle/>
-                    <a:p>
-                      <a:pPr algn="l"/>
-                      <a:r>
-                        <a:rPr sz="1400" b="1">
-                          <a:solidFill>
-                            <a:srgbClr val="5F5E5A"/>
-                          </a:solidFill>
-                          <a:latin typeface="Calibri"/>
-                        </a:rPr>
-                        <a:t>Верно на 25</a:t>
-                      </a:r>
-                    </a:p>
-                  </a:txBody>
-                  <a:tcPr marL="73152" marR="73152" marT="27432" marB="27432" anchor="ctr">
-                    <a:solidFill>
-                      <a:srgbClr val="F1F4F8"/>
-                    </a:solidFill>
-                  </a:tcPr>
-                </a:tc>
-              </a:tr>
-              <a:tr h="457200">
-                <a:tc>
-                  <a:txBody>
-                    <a:bodyPr/>
-                    <a:lstStyle/>
-                    <a:p>
-                      <a:pPr algn="l"/>
-                      <a:r>
-                        <a:rPr sz="1400" b="0">
-                          <a:solidFill>
-                            <a:srgbClr val="1F2328"/>
-                          </a:solidFill>
-                          <a:latin typeface="Calibri"/>
-                        </a:rPr>
-                        <a:t>gpt-4.1</a:t>
-                      </a:r>
-                    </a:p>
-                  </a:txBody>
-                  <a:tcPr marL="73152" marR="73152" marT="27432" marB="27432" anchor="ctr">
-                    <a:solidFill>
-                      <a:srgbClr val="FFFFFF"/>
-                    </a:solidFill>
-                  </a:tcPr>
-                </a:tc>
-                <a:tc>
-                  <a:txBody>
-                    <a:bodyPr/>
-                    <a:lstStyle/>
-                    <a:p>
-                      <a:pPr algn="r"/>
-                      <a:r>
-                        <a:rPr sz="1400" b="0">
-                          <a:solidFill>
-                            <a:srgbClr val="2A78D6"/>
-                          </a:solidFill>
-                          <a:latin typeface="Calibri"/>
-                        </a:rPr>
-                        <a:t>41,7% → 30,8%</a:t>
-                      </a:r>
-                    </a:p>
-                  </a:txBody>
-                  <a:tcPr marL="73152" marR="73152" marT="27432" marB="27432" anchor="ctr">
-                    <a:solidFill>
-                      <a:srgbClr val="FFFFFF"/>
-                    </a:solidFill>
-                  </a:tcPr>
-                </a:tc>
-                <a:tc>
-                  <a:txBody>
-                    <a:bodyPr/>
-                    <a:lstStyle/>
-                    <a:p>
-                      <a:pPr algn="l"/>
-                      <a:r>
-                        <a:rPr sz="1400" b="0">
-                          <a:solidFill>
-                            <a:srgbClr val="1F2328"/>
-                          </a:solidFill>
-                          <a:latin typeface="Calibri"/>
-                        </a:rPr>
-                        <a:t>—</a:t>
-                      </a:r>
-                    </a:p>
-                  </a:txBody>
-                  <a:tcPr marL="73152" marR="73152" marT="27432" marB="27432" anchor="ctr">
-                    <a:solidFill>
-                      <a:srgbClr val="FFFFFF"/>
-                    </a:solidFill>
-                  </a:tcPr>
-                </a:tc>
-                <a:tc>
-                  <a:txBody>
-                    <a:bodyPr/>
-                    <a:lstStyle/>
-                    <a:p>
-                      <a:pPr algn="l"/>
-                      <a:r>
-                        <a:rPr sz="1400" b="0">
-                          <a:solidFill>
-                            <a:srgbClr val="1F2328"/>
-                          </a:solidFill>
-                          <a:latin typeface="Calibri"/>
-                        </a:rPr>
-                        <a:t>0,83 / 0,90</a:t>
-                      </a:r>
-                    </a:p>
-                  </a:txBody>
-                  <a:tcPr marL="73152" marR="73152" marT="27432" marB="27432" anchor="ctr">
-                    <a:solidFill>
-                      <a:srgbClr val="FFFFFF"/>
-                    </a:solidFill>
-                  </a:tcPr>
-                </a:tc>
-                <a:tc>
-                  <a:txBody>
-                    <a:bodyPr/>
-                    <a:lstStyle/>
-                    <a:p>
-                      <a:pPr algn="l"/>
-                      <a:r>
-                        <a:rPr sz="1400" b="0">
-                          <a:solidFill>
-                            <a:srgbClr val="1F2328"/>
-                          </a:solidFill>
-                          <a:latin typeface="Calibri"/>
-                        </a:rPr>
-                        <a:t>14 из 25</a:t>
-                      </a:r>
-                    </a:p>
-                  </a:txBody>
-                  <a:tcPr marL="73152" marR="73152" marT="27432" marB="27432" anchor="ctr">
-                    <a:solidFill>
-                      <a:srgbClr val="FFFFFF"/>
-                    </a:solidFill>
-                  </a:tcPr>
-                </a:tc>
-              </a:tr>
-              <a:tr h="457200">
-                <a:tc>
-                  <a:txBody>
-                    <a:bodyPr/>
-                    <a:lstStyle/>
-                    <a:p>
-                      <a:pPr algn="l"/>
-                      <a:r>
-                        <a:rPr sz="1400" b="0">
-                          <a:solidFill>
-                            <a:srgbClr val="1F2328"/>
-                          </a:solidFill>
-                          <a:latin typeface="Calibri"/>
-                        </a:rPr>
-                        <a:t>Qwen2.5-14B</a:t>
-                      </a:r>
-                    </a:p>
-                  </a:txBody>
-                  <a:tcPr marL="73152" marR="73152" marT="27432" marB="27432" anchor="ctr">
-                    <a:solidFill>
-                      <a:srgbClr val="FFFFFF"/>
-                    </a:solidFill>
-                  </a:tcPr>
-                </a:tc>
-                <a:tc>
-                  <a:txBody>
-                    <a:bodyPr/>
-                    <a:lstStyle/>
-                    <a:p>
-                      <a:pPr algn="r"/>
-                      <a:r>
-                        <a:rPr sz="1400" b="0">
-                          <a:solidFill>
-                            <a:srgbClr val="2A78D6"/>
-                          </a:solidFill>
-                          <a:latin typeface="Calibri"/>
-                        </a:rPr>
-                        <a:t>35,8% → 44,2%</a:t>
-                      </a:r>
-                    </a:p>
-                  </a:txBody>
-                  <a:tcPr marL="73152" marR="73152" marT="27432" marB="27432" anchor="ctr">
-                    <a:solidFill>
-                      <a:srgbClr val="FFFFFF"/>
-                    </a:solidFill>
-                  </a:tcPr>
-                </a:tc>
-                <a:tc>
-                  <a:txBody>
-                    <a:bodyPr/>
-                    <a:lstStyle/>
-                    <a:p>
-                      <a:pPr algn="l"/>
-                      <a:r>
-                        <a:rPr sz="1400" b="0">
-                          <a:solidFill>
-                            <a:srgbClr val="1F2328"/>
-                          </a:solidFill>
-                          <a:latin typeface="Calibri"/>
-                        </a:rPr>
-                        <a:t>0,35 / 0,34</a:t>
-                      </a:r>
-                    </a:p>
-                  </a:txBody>
-                  <a:tcPr marL="73152" marR="73152" marT="27432" marB="27432" anchor="ctr">
-                    <a:solidFill>
-                      <a:srgbClr val="FFFFFF"/>
-                    </a:solidFill>
-                  </a:tcPr>
-                </a:tc>
-                <a:tc>
-                  <a:txBody>
-                    <a:bodyPr/>
-                    <a:lstStyle/>
-                    <a:p>
-                      <a:pPr algn="l"/>
-                      <a:r>
-                        <a:rPr sz="1400" b="0">
-                          <a:solidFill>
-                            <a:srgbClr val="1F2328"/>
-                          </a:solidFill>
-                          <a:latin typeface="Calibri"/>
-                        </a:rPr>
-                        <a:t>1,00 / 1,00</a:t>
-                      </a:r>
-                    </a:p>
-                  </a:txBody>
-                  <a:tcPr marL="73152" marR="73152" marT="27432" marB="27432" anchor="ctr">
-                    <a:solidFill>
-                      <a:srgbClr val="FFFFFF"/>
-                    </a:solidFill>
-                  </a:tcPr>
-                </a:tc>
-                <a:tc>
-                  <a:txBody>
-                    <a:bodyPr/>
-                    <a:lstStyle/>
-                    <a:p>
-                      <a:pPr algn="l"/>
-                      <a:r>
-                        <a:rPr sz="1400" b="0">
-                          <a:solidFill>
-                            <a:srgbClr val="1F2328"/>
-                          </a:solidFill>
-                          <a:latin typeface="Calibri"/>
-                        </a:rPr>
-                        <a:t>11 из 25</a:t>
-                      </a:r>
-                    </a:p>
-                  </a:txBody>
-                  <a:tcPr marL="73152" marR="73152" marT="27432" marB="27432" anchor="ctr">
-                    <a:solidFill>
-                      <a:srgbClr val="FFFFFF"/>
-                    </a:solidFill>
-                  </a:tcPr>
-                </a:tc>
-              </a:tr>
-              <a:tr h="457200">
-                <a:tc>
-                  <a:txBody>
-                    <a:bodyPr/>
-                    <a:lstStyle/>
-                    <a:p>
-                      <a:pPr algn="l"/>
-                      <a:r>
-                        <a:rPr sz="1400" b="0">
-                          <a:solidFill>
-                            <a:srgbClr val="1F2328"/>
-                          </a:solidFill>
-                          <a:latin typeface="Calibri"/>
-                        </a:rPr>
-                        <a:t>Qwen2.5-32B</a:t>
-                      </a:r>
-                    </a:p>
-                  </a:txBody>
-                  <a:tcPr marL="73152" marR="73152" marT="27432" marB="27432" anchor="ctr">
-                    <a:solidFill>
-                      <a:srgbClr val="FFFFFF"/>
-                    </a:solidFill>
-                  </a:tcPr>
-                </a:tc>
-                <a:tc>
-                  <a:txBody>
-                    <a:bodyPr/>
-                    <a:lstStyle/>
-                    <a:p>
-                      <a:pPr algn="r"/>
-                      <a:r>
-                        <a:rPr sz="1400" b="0">
-                          <a:solidFill>
-                            <a:srgbClr val="2A78D6"/>
-                          </a:solidFill>
-                          <a:latin typeface="Calibri"/>
-                        </a:rPr>
-                        <a:t>17,5% → 34,2%</a:t>
-                      </a:r>
-                    </a:p>
-                  </a:txBody>
-                  <a:tcPr marL="73152" marR="73152" marT="27432" marB="27432" anchor="ctr">
-                    <a:solidFill>
-                      <a:srgbClr val="FFFFFF"/>
-                    </a:solidFill>
-                  </a:tcPr>
-                </a:tc>
-                <a:tc>
-                  <a:txBody>
-                    <a:bodyPr/>
-                    <a:lstStyle/>
-                    <a:p>
-                      <a:pPr algn="l"/>
-                      <a:r>
-                        <a:rPr sz="1400" b="0">
-                          <a:solidFill>
-                            <a:srgbClr val="1F2328"/>
-                          </a:solidFill>
-                          <a:latin typeface="Calibri"/>
-                        </a:rPr>
-                        <a:t>0,20 / 0,32</a:t>
-                      </a:r>
-                    </a:p>
-                  </a:txBody>
-                  <a:tcPr marL="73152" marR="73152" marT="27432" marB="27432" anchor="ctr">
-                    <a:solidFill>
-                      <a:srgbClr val="FFFFFF"/>
-                    </a:solidFill>
-                  </a:tcPr>
-                </a:tc>
-                <a:tc>
-                  <a:txBody>
-                    <a:bodyPr/>
-                    <a:lstStyle/>
-                    <a:p>
-                      <a:pPr algn="l"/>
-                      <a:r>
-                        <a:rPr sz="1400" b="0">
-                          <a:solidFill>
-                            <a:srgbClr val="1F2328"/>
-                          </a:solidFill>
-                          <a:latin typeface="Calibri"/>
-                        </a:rPr>
-                        <a:t>—</a:t>
-                      </a:r>
-                    </a:p>
-                  </a:txBody>
-                  <a:tcPr marL="73152" marR="73152" marT="27432" marB="27432" anchor="ctr">
-                    <a:solidFill>
-                      <a:srgbClr val="FFFFFF"/>
-                    </a:solidFill>
-                  </a:tcPr>
-                </a:tc>
-                <a:tc>
-                  <a:txBody>
-                    <a:bodyPr/>
-                    <a:lstStyle/>
-                    <a:p>
-                      <a:pPr algn="l"/>
-                      <a:r>
-                        <a:rPr sz="1400" b="0">
-                          <a:solidFill>
-                            <a:srgbClr val="1F2328"/>
-                          </a:solidFill>
-                          <a:latin typeface="Calibri"/>
-                        </a:rPr>
-                        <a:t>11 из 25</a:t>
-                      </a:r>
-                    </a:p>
-                  </a:txBody>
-                  <a:tcPr marL="73152" marR="73152" marT="27432" marB="27432" anchor="ctr">
-                    <a:solidFill>
-                      <a:srgbClr val="FFFFFF"/>
-                    </a:solidFill>
-                  </a:tcPr>
-                </a:tc>
-              </a:tr>
-              <a:tr h="457200">
-                <a:tc>
-                  <a:txBody>
-                    <a:bodyPr/>
-                    <a:lstStyle/>
-                    <a:p>
-                      <a:pPr algn="l"/>
-                      <a:r>
-                        <a:rPr sz="1400" b="0">
-                          <a:solidFill>
-                            <a:srgbClr val="1F2328"/>
-                          </a:solidFill>
-                          <a:latin typeface="Calibri"/>
-                        </a:rPr>
-                        <a:t>Gemma3-12B</a:t>
-                      </a:r>
-                    </a:p>
-                  </a:txBody>
-                  <a:tcPr marL="73152" marR="73152" marT="27432" marB="27432" anchor="ctr">
-                    <a:solidFill>
-                      <a:srgbClr val="FFFFFF"/>
-                    </a:solidFill>
-                  </a:tcPr>
-                </a:tc>
-                <a:tc>
-                  <a:txBody>
-                    <a:bodyPr/>
-                    <a:lstStyle/>
-                    <a:p>
-                      <a:pPr algn="r"/>
-                      <a:r>
-                        <a:rPr sz="1400" b="0">
-                          <a:solidFill>
-                            <a:srgbClr val="2A78D6"/>
-                          </a:solidFill>
-                          <a:latin typeface="Calibri"/>
-                        </a:rPr>
-                        <a:t>0,0% → 0,0%</a:t>
-                      </a:r>
-                    </a:p>
-                  </a:txBody>
-                  <a:tcPr marL="73152" marR="73152" marT="27432" marB="27432" anchor="ctr">
-                    <a:solidFill>
-                      <a:srgbClr val="FFFFFF"/>
-                    </a:solidFill>
-                  </a:tcPr>
-                </a:tc>
-                <a:tc>
-                  <a:txBody>
-                    <a:bodyPr/>
-                    <a:lstStyle/>
-                    <a:p>
-                      <a:pPr algn="l"/>
-                      <a:r>
-                        <a:rPr sz="1400" b="0">
-                          <a:solidFill>
-                            <a:srgbClr val="1F2328"/>
-                          </a:solidFill>
-                          <a:latin typeface="Calibri"/>
-                        </a:rPr>
-                        <a:t>0,00 / 0,00</a:t>
-                      </a:r>
-                    </a:p>
-                  </a:txBody>
-                  <a:tcPr marL="73152" marR="73152" marT="27432" marB="27432" anchor="ctr">
-                    <a:solidFill>
-                      <a:srgbClr val="FFFFFF"/>
-                    </a:solidFill>
-                  </a:tcPr>
-                </a:tc>
-                <a:tc>
-                  <a:txBody>
-                    <a:bodyPr/>
-                    <a:lstStyle/>
-                    <a:p>
-                      <a:pPr algn="l"/>
-                      <a:r>
-                        <a:rPr sz="1400" b="0">
-                          <a:solidFill>
-                            <a:srgbClr val="1F2328"/>
-                          </a:solidFill>
-                          <a:latin typeface="Calibri"/>
-                        </a:rPr>
-                        <a:t>—</a:t>
-                      </a:r>
-                    </a:p>
-                  </a:txBody>
-                  <a:tcPr marL="73152" marR="73152" marT="27432" marB="27432" anchor="ctr">
-                    <a:solidFill>
-                      <a:srgbClr val="FFFFFF"/>
-                    </a:solidFill>
-                  </a:tcPr>
-                </a:tc>
-                <a:tc>
-                  <a:txBody>
-                    <a:bodyPr/>
-                    <a:lstStyle/>
-                    <a:p>
-                      <a:pPr algn="l"/>
-                      <a:r>
-                        <a:rPr sz="1400" b="0">
-                          <a:solidFill>
-                            <a:srgbClr val="1F2328"/>
-                          </a:solidFill>
-                          <a:latin typeface="Calibri"/>
-                        </a:rPr>
-                        <a:t>12 из 25</a:t>
-                      </a:r>
-                    </a:p>
-                  </a:txBody>
-                  <a:tcPr marL="73152" marR="73152" marT="27432" marB="27432" anchor="ctr">
-                    <a:solidFill>
-                      <a:srgbClr val="FFFFFF"/>
-                    </a:solidFill>
-                  </a:tcPr>
-                </a:tc>
-              </a:tr>
-            </a:tbl>
-          </a:graphicData>
-        </a:graphic>
-      </p:graphicFrame>
-      <p:sp>
-        <p:nvSpPr>
-          <p:cNvPr id="4" name="TextBox 3"/>
-          <p:cNvSpPr txBox="1"/>
-          <p:nvPr/>
-        </p:nvSpPr>
-        <p:spPr>
-          <a:xfrm>
-            <a:off x="548640" y="3931920"/>
-            <a:ext cx="11064240" cy="2194560"/>
-          </a:xfrm>
-          <a:prstGeom prst="rect">
-            <a:avLst/>
-          </a:prstGeom>
-          <a:noFill/>
-        </p:spPr>
-        <p:txBody>
-          <a:bodyPr wrap="square" lIns="0" rIns="0" tIns="0" bIns="0">
-            <a:spAutoFit/>
-          </a:bodyPr>
-          <a:lstStyle/>
-          <a:p>
-            <a:pPr algn="l">
-              <a:spcAft>
-                <a:spcPts val="800"/>
-              </a:spcAft>
-            </a:pPr>
-            <a:r>
-              <a:rPr sz="1500" b="0">
-                <a:solidFill>
-                  <a:srgbClr val="1F2328"/>
-                </a:solidFill>
-                <a:latin typeface="Calibri"/>
-              </a:rPr>
-              <a:t>Больше параметров не помогает: 32B согласна с gpt-4.1 хуже, чем 14B, и на грязном графе находит вдвое меньше противоречий</a:t>
-            </a:r>
-          </a:p>
-          <a:p>
-            <a:pPr algn="l">
-              <a:spcAft>
-                <a:spcPts val="800"/>
-              </a:spcAft>
-            </a:pPr>
-            <a:r>
-              <a:rPr sz="1500" b="0">
-                <a:solidFill>
-                  <a:srgbClr val="1F2328"/>
-                </a:solidFill>
-                <a:latin typeface="Calibri"/>
-              </a:rPr>
-              <a:t>Gemma3-12B не находит противоречий вообще; «всегда нет» на спорных вершинах угадывает не хуже Qwen</a:t>
-            </a:r>
-          </a:p>
-          <a:p>
-            <a:pPr algn="l">
-              <a:spcAft>
-                <a:spcPts val="800"/>
-              </a:spcAft>
-            </a:pPr>
-            <a:r>
-              <a:rPr sz="1500" b="0">
-                <a:solidFill>
-                  <a:srgbClr val="1F2328"/>
-                </a:solidFill>
-                <a:latin typeface="Calibri"/>
-              </a:rPr>
-              <a:t>Обе Qwen ставят чистый граф ниже грязного — систематический сдвиг, а не шум</a:t>
-            </a:r>
-          </a:p>
-          <a:p>
-            <a:pPr algn="l">
-              <a:spcAft>
-                <a:spcPts val="800"/>
-              </a:spcAft>
-            </a:pPr>
-            <a:r>
-              <a:rPr sz="1500" b="0">
-                <a:solidFill>
-                  <a:srgbClr val="1F2328"/>
-                </a:solidFill>
-                <a:latin typeface="Calibri"/>
-              </a:rPr>
-              <a:t>Слепая разметка 25 спорных вершин: с поправкой gpt-4.1 даёт 39,5% → 31,0%. Судья — gpt-4.1</a:t>
-            </a:r>
-          </a:p>
-        </p:txBody>
-      </p:sp>
-      <p:sp>
-        <p:nvSpPr>
-          <p:cNvPr id="5" name="TextBox 4"/>
-          <p:cNvSpPr txBox="1"/>
-          <p:nvPr/>
-        </p:nvSpPr>
-        <p:spPr>
-          <a:xfrm>
-            <a:off x="548640" y="6263640"/>
-            <a:ext cx="11064240" cy="365760"/>
-          </a:xfrm>
-          <a:prstGeom prst="rect">
-            <a:avLst/>
-          </a:prstGeom>
-          <a:noFill/>
-        </p:spPr>
-        <p:txBody>
-          <a:bodyPr wrap="square" lIns="0" rIns="0" tIns="0" bIns="0">
-            <a:spAutoFit/>
-          </a:bodyPr>
-          <a:lstStyle/>
-          <a:p>
-            <a:pPr algn="l">
-              <a:spcAft>
-                <a:spcPts val="600"/>
-              </a:spcAft>
-            </a:pPr>
-            <a:r>
-              <a:rPr sz="1200" b="0">
-                <a:solidFill>
-                  <a:srgbClr val="5F5E5A"/>
-                </a:solidFill>
-                <a:latin typeface="Calibri"/>
-              </a:rPr>
-              <a:t>Противоречий — доля вершин, грязный → чистый; κ — каппа Коэна по флагу «есть противоречие», грязный / чистый; «Верно на 25» — совпадение со слепой разметкой спорных вершин</a:t>
-            </a:r>
-          </a:p>
-        </p:txBody>
-      </p:sp>
-      <p:sp>
-        <p:nvSpPr>
-          <p:cNvPr id="6" name="TextBox 5"/>
-          <p:cNvSpPr txBox="1"/>
-          <p:nvPr/>
-        </p:nvSpPr>
-        <p:spPr>
-          <a:xfrm>
-            <a:off x="10725912" y="6528816"/>
-            <a:ext cx="914400" cy="237744"/>
-          </a:xfrm>
-          <a:prstGeom prst="rect">
-            <a:avLst/>
-          </a:prstGeom>
-          <a:noFill/>
-        </p:spPr>
-        <p:txBody>
-          <a:bodyPr wrap="square" lIns="0" rIns="0" tIns="0" bIns="0">
-            <a:spAutoFit/>
-          </a:bodyPr>
-          <a:lstStyle/>
-          <a:p>
-            <a:pPr algn="r">
-              <a:spcAft>
-                <a:spcPts val="600"/>
-              </a:spcAft>
-            </a:pPr>
-            <a:r>
-              <a:rPr sz="1100" b="0">
-                <a:solidFill>
-                  <a:srgbClr val="5F5E5A"/>
-                </a:solidFill>
-                <a:latin typeface="Calibri"/>
-              </a:rPr>
-              <a:t>3 / 4</a:t>
-            </a:r>
-          </a:p>
-        </p:txBody>
-      </p:sp>
-    </p:spTree>
-  </p:cSld>
-  <p:clrMapOvr>
-    <a:masterClrMapping/>
-  </p:clrMapOvr>
-</p:sld>
-</file>
-
-<file path=ppt/slides/slide4.xml><?xml version="1.0" encoding="utf-8"?>
 <p:sld xmlns:a="http://schemas.openxmlformats.org/drawingml/2006/main" xmlns:p="http://schemas.openxmlformats.org/presentationml/2006/main" xmlns:r="http://schemas.openxmlformats.org/officeDocument/2006/relationships">
   <p:cSld>
     <p:spTree>
@@ -7547,7 +6640,7 @@
                 </a:solidFill>
                 <a:latin typeface="Calibri"/>
               </a:rPr>
-              <a:t>4 / 4</a:t>
+              <a:t>3 / 3</a:t>
             </a:r>
           </a:p>
         </p:txBody>

</xml_diff>